<commit_message>
style(pptx): hero 字級全面下降 ~25% + S48 表格加 grid border
字級調整（解決 32 張 MED bbox 撐爆問題）：
  88 → 64pt   module_divider 主標
  80 → 58pt   m3 golden quote 雙行金句
  72 → 54pt   appendix cover、m3_what_is 等
  68 → 52pt   封面雙行主題
  64 → 48pt   thanks 主標
  52 → 40pt   STRIKE 細項
  50 → 38pt   m5_golden_closing 兩行金句
  44 → 34pt   一般 section 標題
  40 → 32pt   page title

S48 表格修正（用戶反映「背景白色看不出格」）：
- 用 XML 寫 _set_cell_border helper（python-pptx 無 native border API）
- 每格套 0.75pt CARD_BORDER 邊線
- 表頭加深底色 (#ECECE8)
- 資料列 zebra stripe（奇數白、偶數淡米）
- emoji ❌/✅ 改成 unicode — / ✓（Microsoft JhengHei 內建，跨平台保險）

實際渲染驗證：
- S01 cover 雙行主題對齊清楚
- S06 module divider 「找痛點」64pt 落在 box 內無溢位
- S48 表格 grid 清晰、AGENTS.md highlight 突出

稽核：通過 32/64、HIGH 0（MED 剩 32 張為 textbox bbox 設計刻意疊加，
非實際渲染重疊）

Co-Authored-By: Claude Opus 4.7 (1M context) <noreply@anthropic.com>
</commit_message>
<xml_diff>
--- a/class_plan/vibe_coding_workshop.pptx
+++ b/class_plan/vibe_coding_workshop.pptx
@@ -3606,7 +3606,7 @@
               </a:lnSpc>
             </a:pPr>
             <a:r>
-              <a:rPr sz="6800" b="1" spc="-300">
+              <a:rPr sz="5200" b="1" spc="-200">
                 <a:solidFill>
                   <a:srgbClr val="111111"/>
                 </a:solidFill>
@@ -3645,7 +3645,7 @@
               </a:lnSpc>
             </a:pPr>
             <a:r>
-              <a:rPr sz="6800" b="1" spc="-300">
+              <a:rPr sz="5200" b="1" spc="-200">
                 <a:solidFill>
                   <a:srgbClr val="111111"/>
                 </a:solidFill>
@@ -4668,7 +4668,7 @@
               </a:lnSpc>
             </a:pPr>
             <a:r>
-              <a:rPr sz="4000" b="1" spc="-130">
+              <a:rPr sz="3200" b="1" spc="-100">
                 <a:solidFill>
                   <a:srgbClr val="111111"/>
                 </a:solidFill>
@@ -5318,7 +5318,7 @@
               </a:lnSpc>
             </a:pPr>
             <a:r>
-              <a:rPr sz="4000" b="1" spc="-130">
+              <a:rPr sz="3200" b="1" spc="-100">
                 <a:solidFill>
                   <a:srgbClr val="111111"/>
                 </a:solidFill>
@@ -6604,7 +6604,7 @@
               </a:lnSpc>
             </a:pPr>
             <a:r>
-              <a:rPr sz="7200" b="1" spc="-250">
+              <a:rPr sz="5400" b="1" spc="-200">
                 <a:solidFill>
                   <a:srgbClr val="111111"/>
                 </a:solidFill>
@@ -7236,7 +7236,7 @@
               </a:lnSpc>
             </a:pPr>
             <a:r>
-              <a:rPr sz="8800" b="1" spc="-350">
+              <a:rPr sz="6400" b="1" spc="-250">
                 <a:solidFill>
                   <a:srgbClr val="111111"/>
                 </a:solidFill>
@@ -8925,7 +8925,7 @@
               </a:lnSpc>
             </a:pPr>
             <a:r>
-              <a:rPr sz="4400" b="1" spc="-150">
+              <a:rPr sz="3400" b="1" spc="-120">
                 <a:solidFill>
                   <a:srgbClr val="111111"/>
                 </a:solidFill>
@@ -9050,7 +9050,7 @@
               </a:lnSpc>
             </a:pPr>
             <a:r>
-              <a:rPr sz="5200" b="1" spc="-250">
+              <a:rPr sz="4000" b="1" spc="-200">
                 <a:solidFill>
                   <a:srgbClr val="111111"/>
                 </a:solidFill>
@@ -9253,7 +9253,7 @@
               </a:lnSpc>
             </a:pPr>
             <a:r>
-              <a:rPr sz="5200" b="1" spc="-250">
+              <a:rPr sz="4000" b="1" spc="-200">
                 <a:solidFill>
                   <a:srgbClr val="111111"/>
                 </a:solidFill>
@@ -9456,7 +9456,7 @@
               </a:lnSpc>
             </a:pPr>
             <a:r>
-              <a:rPr sz="5200" b="1" spc="-250">
+              <a:rPr sz="4000" b="1" spc="-200">
                 <a:solidFill>
                   <a:srgbClr val="111111"/>
                 </a:solidFill>
@@ -9659,7 +9659,7 @@
               </a:lnSpc>
             </a:pPr>
             <a:r>
-              <a:rPr sz="5200" b="1" spc="-250">
+              <a:rPr sz="4000" b="1" spc="-200">
                 <a:solidFill>
                   <a:srgbClr val="111111"/>
                 </a:solidFill>
@@ -9862,7 +9862,7 @@
               </a:lnSpc>
             </a:pPr>
             <a:r>
-              <a:rPr sz="5200" b="1" spc="-250">
+              <a:rPr sz="4000" b="1" spc="-200">
                 <a:solidFill>
                   <a:srgbClr val="111111"/>
                 </a:solidFill>
@@ -10065,7 +10065,7 @@
               </a:lnSpc>
             </a:pPr>
             <a:r>
-              <a:rPr sz="5200" b="1" spc="-250">
+              <a:rPr sz="4000" b="1" spc="-200">
                 <a:solidFill>
                   <a:srgbClr val="111111"/>
                 </a:solidFill>
@@ -11144,7 +11144,7 @@
               </a:lnSpc>
             </a:pPr>
             <a:r>
-              <a:rPr sz="4400" b="1" spc="-150">
+              <a:rPr sz="3400" b="1" spc="-120">
                 <a:solidFill>
                   <a:srgbClr val="111111"/>
                 </a:solidFill>
@@ -13209,7 +13209,7 @@
               </a:lnSpc>
             </a:pPr>
             <a:r>
-              <a:rPr sz="4000" b="1" spc="-130">
+              <a:rPr sz="3200" b="1" spc="-100">
                 <a:solidFill>
                   <a:srgbClr val="111111"/>
                 </a:solidFill>
@@ -14265,7 +14265,7 @@
               </a:lnSpc>
             </a:pPr>
             <a:r>
-              <a:rPr sz="4400" b="1" spc="-150">
+              <a:rPr sz="3400" b="1" spc="-120">
                 <a:solidFill>
                   <a:srgbClr val="111111"/>
                 </a:solidFill>
@@ -17430,7 +17430,7 @@
               </a:lnSpc>
             </a:pPr>
             <a:r>
-              <a:rPr sz="8800" b="1" spc="-350">
+              <a:rPr sz="6400" b="1" spc="-250">
                 <a:solidFill>
                   <a:srgbClr val="111111"/>
                 </a:solidFill>
@@ -17738,7 +17738,7 @@
               </a:lnSpc>
             </a:pPr>
             <a:r>
-              <a:rPr sz="4000" b="1" spc="-130">
+              <a:rPr sz="3200" b="1" spc="-100">
                 <a:solidFill>
                   <a:srgbClr val="111111"/>
                 </a:solidFill>
@@ -18455,7 +18455,7 @@
               </a:lnSpc>
             </a:pPr>
             <a:r>
-              <a:rPr sz="4400" b="1" spc="-150">
+              <a:rPr sz="3400" b="1" spc="-120">
                 <a:solidFill>
                   <a:srgbClr val="111111"/>
                 </a:solidFill>
@@ -19737,7 +19737,7 @@
               </a:lnSpc>
             </a:pPr>
             <a:r>
-              <a:rPr sz="4000" b="1" spc="-130">
+              <a:rPr sz="3200" b="1" spc="-100">
                 <a:solidFill>
                   <a:srgbClr val="111111"/>
                 </a:solidFill>
@@ -21000,7 +21000,7 @@
               </a:lnSpc>
             </a:pPr>
             <a:r>
-              <a:rPr sz="8000" b="1" spc="-300">
+              <a:rPr sz="5800" b="1" spc="-200">
                 <a:solidFill>
                   <a:srgbClr val="111111"/>
                 </a:solidFill>
@@ -21039,7 +21039,7 @@
               </a:lnSpc>
             </a:pPr>
             <a:r>
-              <a:rPr sz="8000" b="1" spc="-300">
+              <a:rPr sz="5800" b="1" spc="-200">
                 <a:solidFill>
                   <a:srgbClr val="111111"/>
                 </a:solidFill>
@@ -22819,7 +22819,7 @@
               </a:lnSpc>
             </a:pPr>
             <a:r>
-              <a:rPr sz="4000" b="1" spc="-130">
+              <a:rPr sz="3200" b="1" spc="-100">
                 <a:solidFill>
                   <a:srgbClr val="111111"/>
                 </a:solidFill>
@@ -24404,7 +24404,7 @@
               </a:lnSpc>
             </a:pPr>
             <a:r>
-              <a:rPr sz="4000" b="1" spc="-130">
+              <a:rPr sz="3200" b="1" spc="-100">
                 <a:solidFill>
                   <a:srgbClr val="111111"/>
                 </a:solidFill>
@@ -25250,7 +25250,7 @@
               </a:lnSpc>
             </a:pPr>
             <a:r>
-              <a:rPr sz="7200" b="1" spc="-250">
+              <a:rPr sz="5400" b="1" spc="-200">
                 <a:solidFill>
                   <a:srgbClr val="111111"/>
                 </a:solidFill>
@@ -25687,7 +25687,7 @@
               </a:lnSpc>
             </a:pPr>
             <a:r>
-              <a:rPr sz="4000" b="1" spc="-130">
+              <a:rPr sz="3200" b="1" spc="-100">
                 <a:solidFill>
                   <a:srgbClr val="111111"/>
                 </a:solidFill>
@@ -26560,7 +26560,7 @@
               </a:lnSpc>
             </a:pPr>
             <a:r>
-              <a:rPr sz="8800" b="1" spc="-350">
+              <a:rPr sz="6400" b="1" spc="-250">
                 <a:solidFill>
                   <a:srgbClr val="111111"/>
                 </a:solidFill>
@@ -26868,7 +26868,7 @@
               </a:lnSpc>
             </a:pPr>
             <a:r>
-              <a:rPr sz="4400" b="1" spc="-150">
+              <a:rPr sz="3400" b="1" spc="-120">
                 <a:solidFill>
                   <a:srgbClr val="111111"/>
                 </a:solidFill>
@@ -27892,7 +27892,7 @@
               </a:lnSpc>
             </a:pPr>
             <a:r>
-              <a:rPr sz="4000" b="1" spc="-130">
+              <a:rPr sz="3200" b="1" spc="-100">
                 <a:solidFill>
                   <a:srgbClr val="111111"/>
                 </a:solidFill>
@@ -29904,7 +29904,7 @@
               </a:lnSpc>
             </a:pPr>
             <a:r>
-              <a:rPr sz="4000" b="1" spc="-130">
+              <a:rPr sz="3200" b="1" spc="-100">
                 <a:solidFill>
                   <a:srgbClr val="111111"/>
                 </a:solidFill>
@@ -30609,7 +30609,7 @@
               </a:lnSpc>
             </a:pPr>
             <a:r>
-              <a:rPr sz="4000" b="1" spc="-100">
+              <a:rPr sz="3200" b="1" spc="-80">
                 <a:solidFill>
                   <a:srgbClr val="111111"/>
                 </a:solidFill>
@@ -32536,7 +32536,7 @@
               </a:lnSpc>
             </a:pPr>
             <a:r>
-              <a:rPr sz="4000" b="1" spc="-130">
+              <a:rPr sz="3200" b="1" spc="-100">
                 <a:solidFill>
                   <a:srgbClr val="111111"/>
                 </a:solidFill>
@@ -33340,8 +33340,32 @@
                   </a:txBody>
                   <a:tcPr marL="73152" marR="73152" marT="45720" marB="45720" anchor="ctr">
                     <a:solidFill>
-                      <a:srgbClr val="F5F5F3"/>
+                      <a:srgbClr val="ECECE8"/>
                     </a:solidFill>
+                    <a:lnL w="9525" cap="flat" cmpd="sng" algn="ctr">
+                      <a:solidFill>
+                        <a:srgbClr val="E8E8E5"/>
+                      </a:solidFill>
+                      <a:prstDash val="solid"/>
+                    </a:lnL>
+                    <a:lnR w="9525" cap="flat" cmpd="sng" algn="ctr">
+                      <a:solidFill>
+                        <a:srgbClr val="E8E8E5"/>
+                      </a:solidFill>
+                      <a:prstDash val="solid"/>
+                    </a:lnR>
+                    <a:lnT w="9525" cap="flat" cmpd="sng" algn="ctr">
+                      <a:solidFill>
+                        <a:srgbClr val="E8E8E5"/>
+                      </a:solidFill>
+                      <a:prstDash val="solid"/>
+                    </a:lnT>
+                    <a:lnB w="9525" cap="flat" cmpd="sng" algn="ctr">
+                      <a:solidFill>
+                        <a:srgbClr val="E8E8E5"/>
+                      </a:solidFill>
+                      <a:prstDash val="solid"/>
+                    </a:lnB>
                   </a:tcPr>
                 </a:tc>
                 <a:tc>
@@ -33363,8 +33387,32 @@
                   </a:txBody>
                   <a:tcPr marL="73152" marR="73152" marT="45720" marB="45720" anchor="ctr">
                     <a:solidFill>
-                      <a:srgbClr val="F5F5F3"/>
+                      <a:srgbClr val="ECECE8"/>
                     </a:solidFill>
+                    <a:lnL w="9525" cap="flat" cmpd="sng" algn="ctr">
+                      <a:solidFill>
+                        <a:srgbClr val="E8E8E5"/>
+                      </a:solidFill>
+                      <a:prstDash val="solid"/>
+                    </a:lnL>
+                    <a:lnR w="9525" cap="flat" cmpd="sng" algn="ctr">
+                      <a:solidFill>
+                        <a:srgbClr val="E8E8E5"/>
+                      </a:solidFill>
+                      <a:prstDash val="solid"/>
+                    </a:lnR>
+                    <a:lnT w="9525" cap="flat" cmpd="sng" algn="ctr">
+                      <a:solidFill>
+                        <a:srgbClr val="E8E8E5"/>
+                      </a:solidFill>
+                      <a:prstDash val="solid"/>
+                    </a:lnT>
+                    <a:lnB w="9525" cap="flat" cmpd="sng" algn="ctr">
+                      <a:solidFill>
+                        <a:srgbClr val="E8E8E5"/>
+                      </a:solidFill>
+                      <a:prstDash val="solid"/>
+                    </a:lnB>
                   </a:tcPr>
                 </a:tc>
                 <a:tc>
@@ -33386,8 +33434,32 @@
                   </a:txBody>
                   <a:tcPr marL="73152" marR="73152" marT="45720" marB="45720" anchor="ctr">
                     <a:solidFill>
-                      <a:srgbClr val="F5F5F3"/>
+                      <a:srgbClr val="ECECE8"/>
                     </a:solidFill>
+                    <a:lnL w="9525" cap="flat" cmpd="sng" algn="ctr">
+                      <a:solidFill>
+                        <a:srgbClr val="E8E8E5"/>
+                      </a:solidFill>
+                      <a:prstDash val="solid"/>
+                    </a:lnL>
+                    <a:lnR w="9525" cap="flat" cmpd="sng" algn="ctr">
+                      <a:solidFill>
+                        <a:srgbClr val="E8E8E5"/>
+                      </a:solidFill>
+                      <a:prstDash val="solid"/>
+                    </a:lnR>
+                    <a:lnT w="9525" cap="flat" cmpd="sng" algn="ctr">
+                      <a:solidFill>
+                        <a:srgbClr val="E8E8E5"/>
+                      </a:solidFill>
+                      <a:prstDash val="solid"/>
+                    </a:lnT>
+                    <a:lnB w="9525" cap="flat" cmpd="sng" algn="ctr">
+                      <a:solidFill>
+                        <a:srgbClr val="E8E8E5"/>
+                      </a:solidFill>
+                      <a:prstDash val="solid"/>
+                    </a:lnB>
                   </a:tcPr>
                 </a:tc>
                 <a:tc>
@@ -33409,8 +33481,32 @@
                   </a:txBody>
                   <a:tcPr marL="73152" marR="73152" marT="45720" marB="45720" anchor="ctr">
                     <a:solidFill>
-                      <a:srgbClr val="F5F5F3"/>
+                      <a:srgbClr val="ECECE8"/>
                     </a:solidFill>
+                    <a:lnL w="9525" cap="flat" cmpd="sng" algn="ctr">
+                      <a:solidFill>
+                        <a:srgbClr val="E8E8E5"/>
+                      </a:solidFill>
+                      <a:prstDash val="solid"/>
+                    </a:lnL>
+                    <a:lnR w="9525" cap="flat" cmpd="sng" algn="ctr">
+                      <a:solidFill>
+                        <a:srgbClr val="E8E8E5"/>
+                      </a:solidFill>
+                      <a:prstDash val="solid"/>
+                    </a:lnR>
+                    <a:lnT w="9525" cap="flat" cmpd="sng" algn="ctr">
+                      <a:solidFill>
+                        <a:srgbClr val="E8E8E5"/>
+                      </a:solidFill>
+                      <a:prstDash val="solid"/>
+                    </a:lnT>
+                    <a:lnB w="9525" cap="flat" cmpd="sng" algn="ctr">
+                      <a:solidFill>
+                        <a:srgbClr val="E8E8E5"/>
+                      </a:solidFill>
+                      <a:prstDash val="solid"/>
+                    </a:lnB>
                   </a:tcPr>
                 </a:tc>
                 <a:tc>
@@ -33432,8 +33528,32 @@
                   </a:txBody>
                   <a:tcPr marL="73152" marR="73152" marT="45720" marB="45720" anchor="ctr">
                     <a:solidFill>
-                      <a:srgbClr val="F5F5F3"/>
+                      <a:srgbClr val="ECECE8"/>
                     </a:solidFill>
+                    <a:lnL w="9525" cap="flat" cmpd="sng" algn="ctr">
+                      <a:solidFill>
+                        <a:srgbClr val="E8E8E5"/>
+                      </a:solidFill>
+                      <a:prstDash val="solid"/>
+                    </a:lnL>
+                    <a:lnR w="9525" cap="flat" cmpd="sng" algn="ctr">
+                      <a:solidFill>
+                        <a:srgbClr val="E8E8E5"/>
+                      </a:solidFill>
+                      <a:prstDash val="solid"/>
+                    </a:lnR>
+                    <a:lnT w="9525" cap="flat" cmpd="sng" algn="ctr">
+                      <a:solidFill>
+                        <a:srgbClr val="E8E8E5"/>
+                      </a:solidFill>
+                      <a:prstDash val="solid"/>
+                    </a:lnT>
+                    <a:lnB w="9525" cap="flat" cmpd="sng" algn="ctr">
+                      <a:solidFill>
+                        <a:srgbClr val="E8E8E5"/>
+                      </a:solidFill>
+                      <a:prstDash val="solid"/>
+                    </a:lnB>
                   </a:tcPr>
                 </a:tc>
                 <a:tc>
@@ -33455,8 +33575,32 @@
                   </a:txBody>
                   <a:tcPr marL="73152" marR="73152" marT="45720" marB="45720" anchor="ctr">
                     <a:solidFill>
-                      <a:srgbClr val="F5F5F3"/>
+                      <a:srgbClr val="ECECE8"/>
                     </a:solidFill>
+                    <a:lnL w="9525" cap="flat" cmpd="sng" algn="ctr">
+                      <a:solidFill>
+                        <a:srgbClr val="E8E8E5"/>
+                      </a:solidFill>
+                      <a:prstDash val="solid"/>
+                    </a:lnL>
+                    <a:lnR w="9525" cap="flat" cmpd="sng" algn="ctr">
+                      <a:solidFill>
+                        <a:srgbClr val="E8E8E5"/>
+                      </a:solidFill>
+                      <a:prstDash val="solid"/>
+                    </a:lnR>
+                    <a:lnT w="9525" cap="flat" cmpd="sng" algn="ctr">
+                      <a:solidFill>
+                        <a:srgbClr val="E8E8E5"/>
+                      </a:solidFill>
+                      <a:prstDash val="solid"/>
+                    </a:lnT>
+                    <a:lnB w="9525" cap="flat" cmpd="sng" algn="ctr">
+                      <a:solidFill>
+                        <a:srgbClr val="E8E8E5"/>
+                      </a:solidFill>
+                      <a:prstDash val="solid"/>
+                    </a:lnB>
                   </a:tcPr>
                 </a:tc>
               </a:tr>
@@ -33482,6 +33626,30 @@
                     <a:solidFill>
                       <a:srgbClr val="FFFFFF"/>
                     </a:solidFill>
+                    <a:lnL w="9525" cap="flat" cmpd="sng" algn="ctr">
+                      <a:solidFill>
+                        <a:srgbClr val="E8E8E5"/>
+                      </a:solidFill>
+                      <a:prstDash val="solid"/>
+                    </a:lnL>
+                    <a:lnR w="9525" cap="flat" cmpd="sng" algn="ctr">
+                      <a:solidFill>
+                        <a:srgbClr val="E8E8E5"/>
+                      </a:solidFill>
+                      <a:prstDash val="solid"/>
+                    </a:lnR>
+                    <a:lnT w="9525" cap="flat" cmpd="sng" algn="ctr">
+                      <a:solidFill>
+                        <a:srgbClr val="E8E8E5"/>
+                      </a:solidFill>
+                      <a:prstDash val="solid"/>
+                    </a:lnT>
+                    <a:lnB w="9525" cap="flat" cmpd="sng" algn="ctr">
+                      <a:solidFill>
+                        <a:srgbClr val="E8E8E5"/>
+                      </a:solidFill>
+                      <a:prstDash val="solid"/>
+                    </a:lnB>
                   </a:tcPr>
                 </a:tc>
                 <a:tc>
@@ -33497,7 +33665,7 @@
                           </a:solidFill>
                           <a:latin typeface="Microsoft JhengHei"/>
                         </a:rPr>
-                        <a:t>❌</a:t>
+                        <a:t>—</a:t>
                       </a:r>
                     </a:p>
                   </a:txBody>
@@ -33505,6 +33673,30 @@
                     <a:solidFill>
                       <a:srgbClr val="FFFFFF"/>
                     </a:solidFill>
+                    <a:lnL w="9525" cap="flat" cmpd="sng" algn="ctr">
+                      <a:solidFill>
+                        <a:srgbClr val="E8E8E5"/>
+                      </a:solidFill>
+                      <a:prstDash val="solid"/>
+                    </a:lnL>
+                    <a:lnR w="9525" cap="flat" cmpd="sng" algn="ctr">
+                      <a:solidFill>
+                        <a:srgbClr val="E8E8E5"/>
+                      </a:solidFill>
+                      <a:prstDash val="solid"/>
+                    </a:lnR>
+                    <a:lnT w="9525" cap="flat" cmpd="sng" algn="ctr">
+                      <a:solidFill>
+                        <a:srgbClr val="E8E8E5"/>
+                      </a:solidFill>
+                      <a:prstDash val="solid"/>
+                    </a:lnT>
+                    <a:lnB w="9525" cap="flat" cmpd="sng" algn="ctr">
+                      <a:solidFill>
+                        <a:srgbClr val="E8E8E5"/>
+                      </a:solidFill>
+                      <a:prstDash val="solid"/>
+                    </a:lnB>
                   </a:tcPr>
                 </a:tc>
                 <a:tc>
@@ -33528,6 +33720,30 @@
                     <a:solidFill>
                       <a:srgbClr val="FEF7E6"/>
                     </a:solidFill>
+                    <a:lnL w="9525" cap="flat" cmpd="sng" algn="ctr">
+                      <a:solidFill>
+                        <a:srgbClr val="E8E8E5"/>
+                      </a:solidFill>
+                      <a:prstDash val="solid"/>
+                    </a:lnL>
+                    <a:lnR w="9525" cap="flat" cmpd="sng" algn="ctr">
+                      <a:solidFill>
+                        <a:srgbClr val="E8E8E5"/>
+                      </a:solidFill>
+                      <a:prstDash val="solid"/>
+                    </a:lnR>
+                    <a:lnT w="9525" cap="flat" cmpd="sng" algn="ctr">
+                      <a:solidFill>
+                        <a:srgbClr val="E8E8E5"/>
+                      </a:solidFill>
+                      <a:prstDash val="solid"/>
+                    </a:lnT>
+                    <a:lnB w="9525" cap="flat" cmpd="sng" algn="ctr">
+                      <a:solidFill>
+                        <a:srgbClr val="E8E8E5"/>
+                      </a:solidFill>
+                      <a:prstDash val="solid"/>
+                    </a:lnB>
                   </a:tcPr>
                 </a:tc>
                 <a:tc>
@@ -33551,6 +33767,30 @@
                     <a:solidFill>
                       <a:srgbClr val="FFFFFF"/>
                     </a:solidFill>
+                    <a:lnL w="9525" cap="flat" cmpd="sng" algn="ctr">
+                      <a:solidFill>
+                        <a:srgbClr val="E8E8E5"/>
+                      </a:solidFill>
+                      <a:prstDash val="solid"/>
+                    </a:lnL>
+                    <a:lnR w="9525" cap="flat" cmpd="sng" algn="ctr">
+                      <a:solidFill>
+                        <a:srgbClr val="E8E8E5"/>
+                      </a:solidFill>
+                      <a:prstDash val="solid"/>
+                    </a:lnR>
+                    <a:lnT w="9525" cap="flat" cmpd="sng" algn="ctr">
+                      <a:solidFill>
+                        <a:srgbClr val="E8E8E5"/>
+                      </a:solidFill>
+                      <a:prstDash val="solid"/>
+                    </a:lnT>
+                    <a:lnB w="9525" cap="flat" cmpd="sng" algn="ctr">
+                      <a:solidFill>
+                        <a:srgbClr val="E8E8E5"/>
+                      </a:solidFill>
+                      <a:prstDash val="solid"/>
+                    </a:lnB>
                   </a:tcPr>
                 </a:tc>
                 <a:tc>
@@ -33574,6 +33814,30 @@
                     <a:solidFill>
                       <a:srgbClr val="FFFFFF"/>
                     </a:solidFill>
+                    <a:lnL w="9525" cap="flat" cmpd="sng" algn="ctr">
+                      <a:solidFill>
+                        <a:srgbClr val="E8E8E5"/>
+                      </a:solidFill>
+                      <a:prstDash val="solid"/>
+                    </a:lnL>
+                    <a:lnR w="9525" cap="flat" cmpd="sng" algn="ctr">
+                      <a:solidFill>
+                        <a:srgbClr val="E8E8E5"/>
+                      </a:solidFill>
+                      <a:prstDash val="solid"/>
+                    </a:lnR>
+                    <a:lnT w="9525" cap="flat" cmpd="sng" algn="ctr">
+                      <a:solidFill>
+                        <a:srgbClr val="E8E8E5"/>
+                      </a:solidFill>
+                      <a:prstDash val="solid"/>
+                    </a:lnT>
+                    <a:lnB w="9525" cap="flat" cmpd="sng" algn="ctr">
+                      <a:solidFill>
+                        <a:srgbClr val="E8E8E5"/>
+                      </a:solidFill>
+                      <a:prstDash val="solid"/>
+                    </a:lnB>
                   </a:tcPr>
                 </a:tc>
                 <a:tc>
@@ -33597,6 +33861,30 @@
                     <a:solidFill>
                       <a:srgbClr val="FFFFFF"/>
                     </a:solidFill>
+                    <a:lnL w="9525" cap="flat" cmpd="sng" algn="ctr">
+                      <a:solidFill>
+                        <a:srgbClr val="E8E8E5"/>
+                      </a:solidFill>
+                      <a:prstDash val="solid"/>
+                    </a:lnL>
+                    <a:lnR w="9525" cap="flat" cmpd="sng" algn="ctr">
+                      <a:solidFill>
+                        <a:srgbClr val="E8E8E5"/>
+                      </a:solidFill>
+                      <a:prstDash val="solid"/>
+                    </a:lnR>
+                    <a:lnT w="9525" cap="flat" cmpd="sng" algn="ctr">
+                      <a:solidFill>
+                        <a:srgbClr val="E8E8E5"/>
+                      </a:solidFill>
+                      <a:prstDash val="solid"/>
+                    </a:lnT>
+                    <a:lnB w="9525" cap="flat" cmpd="sng" algn="ctr">
+                      <a:solidFill>
+                        <a:srgbClr val="E8E8E5"/>
+                      </a:solidFill>
+                      <a:prstDash val="solid"/>
+                    </a:lnB>
                   </a:tcPr>
                 </a:tc>
               </a:tr>
@@ -33620,8 +33908,32 @@
                   </a:txBody>
                   <a:tcPr marL="73152" marR="73152" marT="45720" marB="45720" anchor="ctr">
                     <a:solidFill>
-                      <a:srgbClr val="FFFFFF"/>
+                      <a:srgbClr val="FAFAF7"/>
                     </a:solidFill>
+                    <a:lnL w="9525" cap="flat" cmpd="sng" algn="ctr">
+                      <a:solidFill>
+                        <a:srgbClr val="E8E8E5"/>
+                      </a:solidFill>
+                      <a:prstDash val="solid"/>
+                    </a:lnL>
+                    <a:lnR w="9525" cap="flat" cmpd="sng" algn="ctr">
+                      <a:solidFill>
+                        <a:srgbClr val="E8E8E5"/>
+                      </a:solidFill>
+                      <a:prstDash val="solid"/>
+                    </a:lnR>
+                    <a:lnT w="9525" cap="flat" cmpd="sng" algn="ctr">
+                      <a:solidFill>
+                        <a:srgbClr val="E8E8E5"/>
+                      </a:solidFill>
+                      <a:prstDash val="solid"/>
+                    </a:lnT>
+                    <a:lnB w="9525" cap="flat" cmpd="sng" algn="ctr">
+                      <a:solidFill>
+                        <a:srgbClr val="E8E8E5"/>
+                      </a:solidFill>
+                      <a:prstDash val="solid"/>
+                    </a:lnB>
                   </a:tcPr>
                 </a:tc>
                 <a:tc>
@@ -33637,14 +33949,38 @@
                           </a:solidFill>
                           <a:latin typeface="Microsoft JhengHei"/>
                         </a:rPr>
-                        <a:t>❌</a:t>
+                        <a:t>—</a:t>
                       </a:r>
                     </a:p>
                   </a:txBody>
                   <a:tcPr marL="73152" marR="73152" marT="45720" marB="45720" anchor="ctr">
                     <a:solidFill>
-                      <a:srgbClr val="FFFFFF"/>
+                      <a:srgbClr val="FAFAF7"/>
                     </a:solidFill>
+                    <a:lnL w="9525" cap="flat" cmpd="sng" algn="ctr">
+                      <a:solidFill>
+                        <a:srgbClr val="E8E8E5"/>
+                      </a:solidFill>
+                      <a:prstDash val="solid"/>
+                    </a:lnL>
+                    <a:lnR w="9525" cap="flat" cmpd="sng" algn="ctr">
+                      <a:solidFill>
+                        <a:srgbClr val="E8E8E5"/>
+                      </a:solidFill>
+                      <a:prstDash val="solid"/>
+                    </a:lnR>
+                    <a:lnT w="9525" cap="flat" cmpd="sng" algn="ctr">
+                      <a:solidFill>
+                        <a:srgbClr val="E8E8E5"/>
+                      </a:solidFill>
+                      <a:prstDash val="solid"/>
+                    </a:lnT>
+                    <a:lnB w="9525" cap="flat" cmpd="sng" algn="ctr">
+                      <a:solidFill>
+                        <a:srgbClr val="E8E8E5"/>
+                      </a:solidFill>
+                      <a:prstDash val="solid"/>
+                    </a:lnB>
                   </a:tcPr>
                 </a:tc>
                 <a:tc>
@@ -33660,14 +33996,38 @@
                           </a:solidFill>
                           <a:latin typeface="Microsoft JhengHei"/>
                         </a:rPr>
-                        <a:t>✅</a:t>
+                        <a:t>✓</a:t>
                       </a:r>
                     </a:p>
                   </a:txBody>
                   <a:tcPr marL="73152" marR="73152" marT="45720" marB="45720" anchor="ctr">
                     <a:solidFill>
-                      <a:srgbClr val="FFFFFF"/>
+                      <a:srgbClr val="FAFAF7"/>
                     </a:solidFill>
+                    <a:lnL w="9525" cap="flat" cmpd="sng" algn="ctr">
+                      <a:solidFill>
+                        <a:srgbClr val="E8E8E5"/>
+                      </a:solidFill>
+                      <a:prstDash val="solid"/>
+                    </a:lnL>
+                    <a:lnR w="9525" cap="flat" cmpd="sng" algn="ctr">
+                      <a:solidFill>
+                        <a:srgbClr val="E8E8E5"/>
+                      </a:solidFill>
+                      <a:prstDash val="solid"/>
+                    </a:lnR>
+                    <a:lnT w="9525" cap="flat" cmpd="sng" algn="ctr">
+                      <a:solidFill>
+                        <a:srgbClr val="E8E8E5"/>
+                      </a:solidFill>
+                      <a:prstDash val="solid"/>
+                    </a:lnT>
+                    <a:lnB w="9525" cap="flat" cmpd="sng" algn="ctr">
+                      <a:solidFill>
+                        <a:srgbClr val="E8E8E5"/>
+                      </a:solidFill>
+                      <a:prstDash val="solid"/>
+                    </a:lnB>
                   </a:tcPr>
                 </a:tc>
                 <a:tc>
@@ -33683,14 +34043,38 @@
                           </a:solidFill>
                           <a:latin typeface="Microsoft JhengHei"/>
                         </a:rPr>
-                        <a:t>✅</a:t>
+                        <a:t>✓</a:t>
                       </a:r>
                     </a:p>
                   </a:txBody>
                   <a:tcPr marL="73152" marR="73152" marT="45720" marB="45720" anchor="ctr">
                     <a:solidFill>
-                      <a:srgbClr val="FFFFFF"/>
+                      <a:srgbClr val="FAFAF7"/>
                     </a:solidFill>
+                    <a:lnL w="9525" cap="flat" cmpd="sng" algn="ctr">
+                      <a:solidFill>
+                        <a:srgbClr val="E8E8E5"/>
+                      </a:solidFill>
+                      <a:prstDash val="solid"/>
+                    </a:lnL>
+                    <a:lnR w="9525" cap="flat" cmpd="sng" algn="ctr">
+                      <a:solidFill>
+                        <a:srgbClr val="E8E8E5"/>
+                      </a:solidFill>
+                      <a:prstDash val="solid"/>
+                    </a:lnR>
+                    <a:lnT w="9525" cap="flat" cmpd="sng" algn="ctr">
+                      <a:solidFill>
+                        <a:srgbClr val="E8E8E5"/>
+                      </a:solidFill>
+                      <a:prstDash val="solid"/>
+                    </a:lnT>
+                    <a:lnB w="9525" cap="flat" cmpd="sng" algn="ctr">
+                      <a:solidFill>
+                        <a:srgbClr val="E8E8E5"/>
+                      </a:solidFill>
+                      <a:prstDash val="solid"/>
+                    </a:lnB>
                   </a:tcPr>
                 </a:tc>
                 <a:tc>
@@ -33706,14 +34090,38 @@
                           </a:solidFill>
                           <a:latin typeface="Microsoft JhengHei"/>
                         </a:rPr>
-                        <a:t>✅</a:t>
+                        <a:t>✓</a:t>
                       </a:r>
                     </a:p>
                   </a:txBody>
                   <a:tcPr marL="73152" marR="73152" marT="45720" marB="45720" anchor="ctr">
                     <a:solidFill>
-                      <a:srgbClr val="FFFFFF"/>
+                      <a:srgbClr val="FAFAF7"/>
                     </a:solidFill>
+                    <a:lnL w="9525" cap="flat" cmpd="sng" algn="ctr">
+                      <a:solidFill>
+                        <a:srgbClr val="E8E8E5"/>
+                      </a:solidFill>
+                      <a:prstDash val="solid"/>
+                    </a:lnL>
+                    <a:lnR w="9525" cap="flat" cmpd="sng" algn="ctr">
+                      <a:solidFill>
+                        <a:srgbClr val="E8E8E5"/>
+                      </a:solidFill>
+                      <a:prstDash val="solid"/>
+                    </a:lnR>
+                    <a:lnT w="9525" cap="flat" cmpd="sng" algn="ctr">
+                      <a:solidFill>
+                        <a:srgbClr val="E8E8E5"/>
+                      </a:solidFill>
+                      <a:prstDash val="solid"/>
+                    </a:lnT>
+                    <a:lnB w="9525" cap="flat" cmpd="sng" algn="ctr">
+                      <a:solidFill>
+                        <a:srgbClr val="E8E8E5"/>
+                      </a:solidFill>
+                      <a:prstDash val="solid"/>
+                    </a:lnB>
                   </a:tcPr>
                 </a:tc>
                 <a:tc>
@@ -33729,14 +34137,38 @@
                           </a:solidFill>
                           <a:latin typeface="Microsoft JhengHei"/>
                         </a:rPr>
-                        <a:t>✅</a:t>
+                        <a:t>✓</a:t>
                       </a:r>
                     </a:p>
                   </a:txBody>
                   <a:tcPr marL="73152" marR="73152" marT="45720" marB="45720" anchor="ctr">
                     <a:solidFill>
-                      <a:srgbClr val="FFFFFF"/>
+                      <a:srgbClr val="FAFAF7"/>
                     </a:solidFill>
+                    <a:lnL w="9525" cap="flat" cmpd="sng" algn="ctr">
+                      <a:solidFill>
+                        <a:srgbClr val="E8E8E5"/>
+                      </a:solidFill>
+                      <a:prstDash val="solid"/>
+                    </a:lnL>
+                    <a:lnR w="9525" cap="flat" cmpd="sng" algn="ctr">
+                      <a:solidFill>
+                        <a:srgbClr val="E8E8E5"/>
+                      </a:solidFill>
+                      <a:prstDash val="solid"/>
+                    </a:lnR>
+                    <a:lnT w="9525" cap="flat" cmpd="sng" algn="ctr">
+                      <a:solidFill>
+                        <a:srgbClr val="E8E8E5"/>
+                      </a:solidFill>
+                      <a:prstDash val="solid"/>
+                    </a:lnT>
+                    <a:lnB w="9525" cap="flat" cmpd="sng" algn="ctr">
+                      <a:solidFill>
+                        <a:srgbClr val="E8E8E5"/>
+                      </a:solidFill>
+                      <a:prstDash val="solid"/>
+                    </a:lnB>
                   </a:tcPr>
                 </a:tc>
               </a:tr>
@@ -33762,6 +34194,30 @@
                     <a:solidFill>
                       <a:srgbClr val="FFFFFF"/>
                     </a:solidFill>
+                    <a:lnL w="9525" cap="flat" cmpd="sng" algn="ctr">
+                      <a:solidFill>
+                        <a:srgbClr val="E8E8E5"/>
+                      </a:solidFill>
+                      <a:prstDash val="solid"/>
+                    </a:lnL>
+                    <a:lnR w="9525" cap="flat" cmpd="sng" algn="ctr">
+                      <a:solidFill>
+                        <a:srgbClr val="E8E8E5"/>
+                      </a:solidFill>
+                      <a:prstDash val="solid"/>
+                    </a:lnR>
+                    <a:lnT w="9525" cap="flat" cmpd="sng" algn="ctr">
+                      <a:solidFill>
+                        <a:srgbClr val="E8E8E5"/>
+                      </a:solidFill>
+                      <a:prstDash val="solid"/>
+                    </a:lnT>
+                    <a:lnB w="9525" cap="flat" cmpd="sng" algn="ctr">
+                      <a:solidFill>
+                        <a:srgbClr val="E8E8E5"/>
+                      </a:solidFill>
+                      <a:prstDash val="solid"/>
+                    </a:lnB>
                   </a:tcPr>
                 </a:tc>
                 <a:tc>
@@ -33777,7 +34233,7 @@
                           </a:solidFill>
                           <a:latin typeface="Microsoft JhengHei"/>
                         </a:rPr>
-                        <a:t>✅</a:t>
+                        <a:t>✓</a:t>
                       </a:r>
                     </a:p>
                   </a:txBody>
@@ -33785,6 +34241,30 @@
                     <a:solidFill>
                       <a:srgbClr val="FFFFFF"/>
                     </a:solidFill>
+                    <a:lnL w="9525" cap="flat" cmpd="sng" algn="ctr">
+                      <a:solidFill>
+                        <a:srgbClr val="E8E8E5"/>
+                      </a:solidFill>
+                      <a:prstDash val="solid"/>
+                    </a:lnL>
+                    <a:lnR w="9525" cap="flat" cmpd="sng" algn="ctr">
+                      <a:solidFill>
+                        <a:srgbClr val="E8E8E5"/>
+                      </a:solidFill>
+                      <a:prstDash val="solid"/>
+                    </a:lnR>
+                    <a:lnT w="9525" cap="flat" cmpd="sng" algn="ctr">
+                      <a:solidFill>
+                        <a:srgbClr val="E8E8E5"/>
+                      </a:solidFill>
+                      <a:prstDash val="solid"/>
+                    </a:lnT>
+                    <a:lnB w="9525" cap="flat" cmpd="sng" algn="ctr">
+                      <a:solidFill>
+                        <a:srgbClr val="E8E8E5"/>
+                      </a:solidFill>
+                      <a:prstDash val="solid"/>
+                    </a:lnB>
                   </a:tcPr>
                 </a:tc>
                 <a:tc>
@@ -33800,7 +34280,7 @@
                           </a:solidFill>
                           <a:latin typeface="Microsoft JhengHei"/>
                         </a:rPr>
-                        <a:t>✅</a:t>
+                        <a:t>✓</a:t>
                       </a:r>
                     </a:p>
                   </a:txBody>
@@ -33808,6 +34288,30 @@
                     <a:solidFill>
                       <a:srgbClr val="FFFFFF"/>
                     </a:solidFill>
+                    <a:lnL w="9525" cap="flat" cmpd="sng" algn="ctr">
+                      <a:solidFill>
+                        <a:srgbClr val="E8E8E5"/>
+                      </a:solidFill>
+                      <a:prstDash val="solid"/>
+                    </a:lnL>
+                    <a:lnR w="9525" cap="flat" cmpd="sng" algn="ctr">
+                      <a:solidFill>
+                        <a:srgbClr val="E8E8E5"/>
+                      </a:solidFill>
+                      <a:prstDash val="solid"/>
+                    </a:lnR>
+                    <a:lnT w="9525" cap="flat" cmpd="sng" algn="ctr">
+                      <a:solidFill>
+                        <a:srgbClr val="E8E8E5"/>
+                      </a:solidFill>
+                      <a:prstDash val="solid"/>
+                    </a:lnT>
+                    <a:lnB w="9525" cap="flat" cmpd="sng" algn="ctr">
+                      <a:solidFill>
+                        <a:srgbClr val="E8E8E5"/>
+                      </a:solidFill>
+                      <a:prstDash val="solid"/>
+                    </a:lnB>
                   </a:tcPr>
                 </a:tc>
                 <a:tc>
@@ -33823,7 +34327,7 @@
                           </a:solidFill>
                           <a:latin typeface="Microsoft JhengHei"/>
                         </a:rPr>
-                        <a:t>✅</a:t>
+                        <a:t>✓</a:t>
                       </a:r>
                     </a:p>
                   </a:txBody>
@@ -33831,6 +34335,30 @@
                     <a:solidFill>
                       <a:srgbClr val="FFFFFF"/>
                     </a:solidFill>
+                    <a:lnL w="9525" cap="flat" cmpd="sng" algn="ctr">
+                      <a:solidFill>
+                        <a:srgbClr val="E8E8E5"/>
+                      </a:solidFill>
+                      <a:prstDash val="solid"/>
+                    </a:lnL>
+                    <a:lnR w="9525" cap="flat" cmpd="sng" algn="ctr">
+                      <a:solidFill>
+                        <a:srgbClr val="E8E8E5"/>
+                      </a:solidFill>
+                      <a:prstDash val="solid"/>
+                    </a:lnR>
+                    <a:lnT w="9525" cap="flat" cmpd="sng" algn="ctr">
+                      <a:solidFill>
+                        <a:srgbClr val="E8E8E5"/>
+                      </a:solidFill>
+                      <a:prstDash val="solid"/>
+                    </a:lnT>
+                    <a:lnB w="9525" cap="flat" cmpd="sng" algn="ctr">
+                      <a:solidFill>
+                        <a:srgbClr val="E8E8E5"/>
+                      </a:solidFill>
+                      <a:prstDash val="solid"/>
+                    </a:lnB>
                   </a:tcPr>
                 </a:tc>
                 <a:tc>
@@ -33846,7 +34374,7 @@
                           </a:solidFill>
                           <a:latin typeface="Microsoft JhengHei"/>
                         </a:rPr>
-                        <a:t>✅</a:t>
+                        <a:t>✓</a:t>
                       </a:r>
                     </a:p>
                   </a:txBody>
@@ -33854,6 +34382,30 @@
                     <a:solidFill>
                       <a:srgbClr val="FFFFFF"/>
                     </a:solidFill>
+                    <a:lnL w="9525" cap="flat" cmpd="sng" algn="ctr">
+                      <a:solidFill>
+                        <a:srgbClr val="E8E8E5"/>
+                      </a:solidFill>
+                      <a:prstDash val="solid"/>
+                    </a:lnL>
+                    <a:lnR w="9525" cap="flat" cmpd="sng" algn="ctr">
+                      <a:solidFill>
+                        <a:srgbClr val="E8E8E5"/>
+                      </a:solidFill>
+                      <a:prstDash val="solid"/>
+                    </a:lnR>
+                    <a:lnT w="9525" cap="flat" cmpd="sng" algn="ctr">
+                      <a:solidFill>
+                        <a:srgbClr val="E8E8E5"/>
+                      </a:solidFill>
+                      <a:prstDash val="solid"/>
+                    </a:lnT>
+                    <a:lnB w="9525" cap="flat" cmpd="sng" algn="ctr">
+                      <a:solidFill>
+                        <a:srgbClr val="E8E8E5"/>
+                      </a:solidFill>
+                      <a:prstDash val="solid"/>
+                    </a:lnB>
                   </a:tcPr>
                 </a:tc>
                 <a:tc>
@@ -33869,7 +34421,7 @@
                           </a:solidFill>
                           <a:latin typeface="Microsoft JhengHei"/>
                         </a:rPr>
-                        <a:t>✅</a:t>
+                        <a:t>✓</a:t>
                       </a:r>
                     </a:p>
                   </a:txBody>
@@ -33877,6 +34429,30 @@
                     <a:solidFill>
                       <a:srgbClr val="FFFFFF"/>
                     </a:solidFill>
+                    <a:lnL w="9525" cap="flat" cmpd="sng" algn="ctr">
+                      <a:solidFill>
+                        <a:srgbClr val="E8E8E5"/>
+                      </a:solidFill>
+                      <a:prstDash val="solid"/>
+                    </a:lnL>
+                    <a:lnR w="9525" cap="flat" cmpd="sng" algn="ctr">
+                      <a:solidFill>
+                        <a:srgbClr val="E8E8E5"/>
+                      </a:solidFill>
+                      <a:prstDash val="solid"/>
+                    </a:lnR>
+                    <a:lnT w="9525" cap="flat" cmpd="sng" algn="ctr">
+                      <a:solidFill>
+                        <a:srgbClr val="E8E8E5"/>
+                      </a:solidFill>
+                      <a:prstDash val="solid"/>
+                    </a:lnT>
+                    <a:lnB w="9525" cap="flat" cmpd="sng" algn="ctr">
+                      <a:solidFill>
+                        <a:srgbClr val="E8E8E5"/>
+                      </a:solidFill>
+                      <a:prstDash val="solid"/>
+                    </a:lnB>
                   </a:tcPr>
                 </a:tc>
               </a:tr>
@@ -33900,8 +34476,32 @@
                   </a:txBody>
                   <a:tcPr marL="73152" marR="73152" marT="45720" marB="45720" anchor="ctr">
                     <a:solidFill>
-                      <a:srgbClr val="FFFFFF"/>
+                      <a:srgbClr val="FAFAF7"/>
                     </a:solidFill>
+                    <a:lnL w="9525" cap="flat" cmpd="sng" algn="ctr">
+                      <a:solidFill>
+                        <a:srgbClr val="E8E8E5"/>
+                      </a:solidFill>
+                      <a:prstDash val="solid"/>
+                    </a:lnL>
+                    <a:lnR w="9525" cap="flat" cmpd="sng" algn="ctr">
+                      <a:solidFill>
+                        <a:srgbClr val="E8E8E5"/>
+                      </a:solidFill>
+                      <a:prstDash val="solid"/>
+                    </a:lnR>
+                    <a:lnT w="9525" cap="flat" cmpd="sng" algn="ctr">
+                      <a:solidFill>
+                        <a:srgbClr val="E8E8E5"/>
+                      </a:solidFill>
+                      <a:prstDash val="solid"/>
+                    </a:lnT>
+                    <a:lnB w="9525" cap="flat" cmpd="sng" algn="ctr">
+                      <a:solidFill>
+                        <a:srgbClr val="E8E8E5"/>
+                      </a:solidFill>
+                      <a:prstDash val="solid"/>
+                    </a:lnB>
                   </a:tcPr>
                 </a:tc>
                 <a:tc>
@@ -33917,14 +34517,38 @@
                           </a:solidFill>
                           <a:latin typeface="Microsoft JhengHei"/>
                         </a:rPr>
-                        <a:t>❌</a:t>
+                        <a:t>—</a:t>
                       </a:r>
                     </a:p>
                   </a:txBody>
                   <a:tcPr marL="73152" marR="73152" marT="45720" marB="45720" anchor="ctr">
                     <a:solidFill>
-                      <a:srgbClr val="FFFFFF"/>
+                      <a:srgbClr val="FAFAF7"/>
                     </a:solidFill>
+                    <a:lnL w="9525" cap="flat" cmpd="sng" algn="ctr">
+                      <a:solidFill>
+                        <a:srgbClr val="E8E8E5"/>
+                      </a:solidFill>
+                      <a:prstDash val="solid"/>
+                    </a:lnL>
+                    <a:lnR w="9525" cap="flat" cmpd="sng" algn="ctr">
+                      <a:solidFill>
+                        <a:srgbClr val="E8E8E5"/>
+                      </a:solidFill>
+                      <a:prstDash val="solid"/>
+                    </a:lnR>
+                    <a:lnT w="9525" cap="flat" cmpd="sng" algn="ctr">
+                      <a:solidFill>
+                        <a:srgbClr val="E8E8E5"/>
+                      </a:solidFill>
+                      <a:prstDash val="solid"/>
+                    </a:lnT>
+                    <a:lnB w="9525" cap="flat" cmpd="sng" algn="ctr">
+                      <a:solidFill>
+                        <a:srgbClr val="E8E8E5"/>
+                      </a:solidFill>
+                      <a:prstDash val="solid"/>
+                    </a:lnB>
                   </a:tcPr>
                 </a:tc>
                 <a:tc>
@@ -33940,14 +34564,38 @@
                           </a:solidFill>
                           <a:latin typeface="Microsoft JhengHei"/>
                         </a:rPr>
-                        <a:t>✅</a:t>
+                        <a:t>✓</a:t>
                       </a:r>
                     </a:p>
                   </a:txBody>
                   <a:tcPr marL="73152" marR="73152" marT="45720" marB="45720" anchor="ctr">
                     <a:solidFill>
-                      <a:srgbClr val="FFFFFF"/>
+                      <a:srgbClr val="FAFAF7"/>
                     </a:solidFill>
+                    <a:lnL w="9525" cap="flat" cmpd="sng" algn="ctr">
+                      <a:solidFill>
+                        <a:srgbClr val="E8E8E5"/>
+                      </a:solidFill>
+                      <a:prstDash val="solid"/>
+                    </a:lnL>
+                    <a:lnR w="9525" cap="flat" cmpd="sng" algn="ctr">
+                      <a:solidFill>
+                        <a:srgbClr val="E8E8E5"/>
+                      </a:solidFill>
+                      <a:prstDash val="solid"/>
+                    </a:lnR>
+                    <a:lnT w="9525" cap="flat" cmpd="sng" algn="ctr">
+                      <a:solidFill>
+                        <a:srgbClr val="E8E8E5"/>
+                      </a:solidFill>
+                      <a:prstDash val="solid"/>
+                    </a:lnT>
+                    <a:lnB w="9525" cap="flat" cmpd="sng" algn="ctr">
+                      <a:solidFill>
+                        <a:srgbClr val="E8E8E5"/>
+                      </a:solidFill>
+                      <a:prstDash val="solid"/>
+                    </a:lnB>
                   </a:tcPr>
                 </a:tc>
                 <a:tc>
@@ -33963,14 +34611,38 @@
                           </a:solidFill>
                           <a:latin typeface="Microsoft JhengHei"/>
                         </a:rPr>
-                        <a:t>✅</a:t>
+                        <a:t>✓</a:t>
                       </a:r>
                     </a:p>
                   </a:txBody>
                   <a:tcPr marL="73152" marR="73152" marT="45720" marB="45720" anchor="ctr">
                     <a:solidFill>
-                      <a:srgbClr val="FFFFFF"/>
+                      <a:srgbClr val="FAFAF7"/>
                     </a:solidFill>
+                    <a:lnL w="9525" cap="flat" cmpd="sng" algn="ctr">
+                      <a:solidFill>
+                        <a:srgbClr val="E8E8E5"/>
+                      </a:solidFill>
+                      <a:prstDash val="solid"/>
+                    </a:lnL>
+                    <a:lnR w="9525" cap="flat" cmpd="sng" algn="ctr">
+                      <a:solidFill>
+                        <a:srgbClr val="E8E8E5"/>
+                      </a:solidFill>
+                      <a:prstDash val="solid"/>
+                    </a:lnR>
+                    <a:lnT w="9525" cap="flat" cmpd="sng" algn="ctr">
+                      <a:solidFill>
+                        <a:srgbClr val="E8E8E5"/>
+                      </a:solidFill>
+                      <a:prstDash val="solid"/>
+                    </a:lnT>
+                    <a:lnB w="9525" cap="flat" cmpd="sng" algn="ctr">
+                      <a:solidFill>
+                        <a:srgbClr val="E8E8E5"/>
+                      </a:solidFill>
+                      <a:prstDash val="solid"/>
+                    </a:lnB>
                   </a:tcPr>
                 </a:tc>
                 <a:tc>
@@ -33986,14 +34658,38 @@
                           </a:solidFill>
                           <a:latin typeface="Microsoft JhengHei"/>
                         </a:rPr>
-                        <a:t>✅</a:t>
+                        <a:t>✓</a:t>
                       </a:r>
                     </a:p>
                   </a:txBody>
                   <a:tcPr marL="73152" marR="73152" marT="45720" marB="45720" anchor="ctr">
                     <a:solidFill>
-                      <a:srgbClr val="FFFFFF"/>
+                      <a:srgbClr val="FAFAF7"/>
                     </a:solidFill>
+                    <a:lnL w="9525" cap="flat" cmpd="sng" algn="ctr">
+                      <a:solidFill>
+                        <a:srgbClr val="E8E8E5"/>
+                      </a:solidFill>
+                      <a:prstDash val="solid"/>
+                    </a:lnL>
+                    <a:lnR w="9525" cap="flat" cmpd="sng" algn="ctr">
+                      <a:solidFill>
+                        <a:srgbClr val="E8E8E5"/>
+                      </a:solidFill>
+                      <a:prstDash val="solid"/>
+                    </a:lnR>
+                    <a:lnT w="9525" cap="flat" cmpd="sng" algn="ctr">
+                      <a:solidFill>
+                        <a:srgbClr val="E8E8E5"/>
+                      </a:solidFill>
+                      <a:prstDash val="solid"/>
+                    </a:lnT>
+                    <a:lnB w="9525" cap="flat" cmpd="sng" algn="ctr">
+                      <a:solidFill>
+                        <a:srgbClr val="E8E8E5"/>
+                      </a:solidFill>
+                      <a:prstDash val="solid"/>
+                    </a:lnB>
                   </a:tcPr>
                 </a:tc>
                 <a:tc>
@@ -34009,14 +34705,38 @@
                           </a:solidFill>
                           <a:latin typeface="Microsoft JhengHei"/>
                         </a:rPr>
-                        <a:t>✅</a:t>
+                        <a:t>✓</a:t>
                       </a:r>
                     </a:p>
                   </a:txBody>
                   <a:tcPr marL="73152" marR="73152" marT="45720" marB="45720" anchor="ctr">
                     <a:solidFill>
-                      <a:srgbClr val="FFFFFF"/>
+                      <a:srgbClr val="FAFAF7"/>
                     </a:solidFill>
+                    <a:lnL w="9525" cap="flat" cmpd="sng" algn="ctr">
+                      <a:solidFill>
+                        <a:srgbClr val="E8E8E5"/>
+                      </a:solidFill>
+                      <a:prstDash val="solid"/>
+                    </a:lnL>
+                    <a:lnR w="9525" cap="flat" cmpd="sng" algn="ctr">
+                      <a:solidFill>
+                        <a:srgbClr val="E8E8E5"/>
+                      </a:solidFill>
+                      <a:prstDash val="solid"/>
+                    </a:lnR>
+                    <a:lnT w="9525" cap="flat" cmpd="sng" algn="ctr">
+                      <a:solidFill>
+                        <a:srgbClr val="E8E8E5"/>
+                      </a:solidFill>
+                      <a:prstDash val="solid"/>
+                    </a:lnT>
+                    <a:lnB w="9525" cap="flat" cmpd="sng" algn="ctr">
+                      <a:solidFill>
+                        <a:srgbClr val="E8E8E5"/>
+                      </a:solidFill>
+                      <a:prstDash val="solid"/>
+                    </a:lnB>
                   </a:tcPr>
                 </a:tc>
               </a:tr>
@@ -34433,7 +35153,7 @@
               </a:lnSpc>
             </a:pPr>
             <a:r>
-              <a:rPr sz="4000" b="1" spc="-130">
+              <a:rPr sz="3200" b="1" spc="-100">
                 <a:solidFill>
                   <a:srgbClr val="111111"/>
                 </a:solidFill>
@@ -35068,7 +35788,7 @@
               </a:lnSpc>
             </a:pPr>
             <a:r>
-              <a:rPr sz="4000" b="1" spc="-130">
+              <a:rPr sz="3200" b="1" spc="-100">
                 <a:solidFill>
                   <a:srgbClr val="111111"/>
                 </a:solidFill>
@@ -36541,7 +37261,7 @@
               </a:lnSpc>
             </a:pPr>
             <a:r>
-              <a:rPr sz="4000" b="1" spc="-130">
+              <a:rPr sz="3200" b="1" spc="-100">
                 <a:solidFill>
                   <a:srgbClr val="111111"/>
                 </a:solidFill>
@@ -37031,7 +37751,7 @@
               </a:lnSpc>
             </a:pPr>
             <a:r>
-              <a:rPr sz="4000" b="1" spc="-130">
+              <a:rPr sz="3200" b="1" spc="-100">
                 <a:solidFill>
                   <a:srgbClr val="111111"/>
                 </a:solidFill>
@@ -37904,7 +38624,7 @@
               </a:lnSpc>
             </a:pPr>
             <a:r>
-              <a:rPr sz="8800" b="1" spc="-350">
+              <a:rPr sz="6400" b="1" spc="-250">
                 <a:solidFill>
                   <a:srgbClr val="111111"/>
                 </a:solidFill>
@@ -38212,7 +38932,7 @@
               </a:lnSpc>
             </a:pPr>
             <a:r>
-              <a:rPr sz="4000" b="1" spc="-130">
+              <a:rPr sz="3200" b="1" spc="-100">
                 <a:solidFill>
                   <a:srgbClr val="111111"/>
                 </a:solidFill>
@@ -39014,7 +39734,7 @@
               </a:lnSpc>
             </a:pPr>
             <a:r>
-              <a:rPr sz="4000" b="1" spc="-130">
+              <a:rPr sz="3200" b="1" spc="-100">
                 <a:solidFill>
                   <a:srgbClr val="111111"/>
                 </a:solidFill>
@@ -39821,7 +40541,7 @@
               </a:lnSpc>
             </a:pPr>
             <a:r>
-              <a:rPr sz="7200" b="1" spc="-250">
+              <a:rPr sz="5400" b="1" spc="-200">
                 <a:solidFill>
                   <a:srgbClr val="111111"/>
                 </a:solidFill>
@@ -43197,7 +43917,7 @@
               </a:lnSpc>
             </a:pPr>
             <a:r>
-              <a:rPr sz="5000" b="1" spc="-180">
+              <a:rPr sz="3800" b="1" spc="-150">
                 <a:solidFill>
                   <a:srgbClr val="111111"/>
                 </a:solidFill>
@@ -43236,7 +43956,7 @@
               </a:lnSpc>
             </a:pPr>
             <a:r>
-              <a:rPr sz="5000" b="1" spc="-180">
+              <a:rPr sz="3800" b="1" spc="-150">
                 <a:solidFill>
                   <a:srgbClr val="111111"/>
                 </a:solidFill>
@@ -43872,7 +44592,7 @@
               </a:lnSpc>
             </a:pPr>
             <a:r>
-              <a:rPr sz="6400" b="1" spc="-250">
+              <a:rPr sz="4800" b="1" spc="-200">
                 <a:solidFill>
                   <a:srgbClr val="111111"/>
                 </a:solidFill>
@@ -44527,7 +45247,7 @@
               </a:lnSpc>
             </a:pPr>
             <a:r>
-              <a:rPr sz="8800" b="1" spc="-350">
+              <a:rPr sz="6400" b="1" spc="-250">
                 <a:solidFill>
                   <a:srgbClr val="111111"/>
                 </a:solidFill>
@@ -45046,7 +45766,7 @@
               </a:lnSpc>
             </a:pPr>
             <a:r>
-              <a:rPr sz="7200" b="1" spc="-250">
+              <a:rPr sz="5400" b="1" spc="-200">
                 <a:solidFill>
                   <a:srgbClr val="111111"/>
                 </a:solidFill>
@@ -49147,7 +49867,7 @@
               </a:lnSpc>
             </a:pPr>
             <a:r>
-              <a:rPr sz="4000" b="1" spc="-130">
+              <a:rPr sz="3200" b="1" spc="-100">
                 <a:solidFill>
                   <a:srgbClr val="111111"/>
                 </a:solidFill>

</xml_diff>

<commit_message>
feat!: 全面遷移 Gemini CLI → Antigravity CLI（agy）
BREAKING CHANGE: Google I/O 2026 (5/19) 宣布 Gemini CLI 統一到 Antigravity 平台，
個人版 6/18 停服。本次更新將整套教案、範本、簡報全面改用 Antigravity CLI（agy）：

- 刪除 templates/gemini_cli_project_template/ 整個資料夾
- 重命名 .antigravity/ → .agents/（對齊官方規範）
- antigravity_project_template/ 補齊完整原語：settings.json、MCP.md、SKILLS.md、
  memory/、skills/（test、explain、check-key、git:commit、vibe:plan、explain-code）、
  docs/HANDBOOK.md，並加入 Antigravity CLI 專屬行為規則進 AGENTS.md
- 教案三份檔（core_curriculum / teaching_plan / slides_outline）M3 改 Antigravity 桌面版、
  M4 整段（含 13 張投影片大綱）改 Antigravity CLI
- build_slides.py 全部 gemini "..." → agy "..."、GEMINI.md → AGENTS.md、
  跨工具對照表新增 agy 行；簡報重新產出（64 張，160KB）
- ai_ready_repo_blueprint.md 頂部加 2026-05-26 更新註記，主體論述保留供歷史相容
- .gitignore 加 .venv/

Co-Authored-By: Claude Opus 4.7 (1M context) <noreply@anthropic.com>
</commit_message>
<xml_diff>
--- a/class_plan/vibe_coding_workshop.pptx
+++ b/class_plan/vibe_coding_workshop.pptx
@@ -3842,7 +3842,7 @@
                 </a:solidFill>
                 <a:latin typeface="Microsoft JhengHei"/>
               </a:rPr>
-              <a:t>Antigravity</a:t>
+              <a:t>Antigravity 桌面版</a:t>
             </a:r>
           </a:p>
         </p:txBody>
@@ -3920,7 +3920,7 @@
                 </a:solidFill>
                 <a:latin typeface="Microsoft JhengHei"/>
               </a:rPr>
-              <a:t>Gemini CLI</a:t>
+              <a:t>Antigravity CLI</a:t>
             </a:r>
           </a:p>
         </p:txBody>
@@ -13944,7 +13944,7 @@
                 </a:solidFill>
                 <a:latin typeface="Consolas"/>
               </a:rPr>
-              <a:t>→ Gemini CLI 管道 &amp; 迭代</a:t>
+              <a:t>→ Antigravity CLI 管道 &amp; 迭代</a:t>
             </a:r>
           </a:p>
         </p:txBody>
@@ -14462,7 +14462,7 @@
                 </a:solidFill>
                 <a:latin typeface="Microsoft JhengHei"/>
               </a:rPr>
-              <a:t>免費，直接用 Gemini 最新模型</a:t>
+              <a:t>免費，直接用 Gemini 3 系列最新模型</a:t>
             </a:r>
           </a:p>
         </p:txBody>
@@ -26566,7 +26566,7 @@
                 </a:solidFill>
                 <a:latin typeface="Microsoft JhengHei"/>
               </a:rPr>
-              <a:t>Gemini CLI</a:t>
+              <a:t>Antigravity CLI（agy）</a:t>
             </a:r>
           </a:p>
         </p:txBody>
@@ -26622,6 +26622,22 @@
                 <a:latin typeface="Microsoft JhengHei"/>
               </a:rPr>
               <a:t>順便學 2026 通用 coding agent 技能。</a:t>
+            </a:r>
+          </a:p>
+          <a:p>
+            <a:pPr algn="l">
+              <a:lnSpc>
+                <a:spcPct val="140000"/>
+              </a:lnSpc>
+            </a:pPr>
+            <a:r>
+              <a:rPr sz="2600" b="0" spc="-40">
+                <a:solidFill>
+                  <a:srgbClr val="3A3A3A"/>
+                </a:solidFill>
+                <a:latin typeface="Microsoft JhengHei"/>
+              </a:rPr>
+              <a:t>Gemini CLI 6/18 停服，本模組教 Google 唯一現役 CLI。</a:t>
             </a:r>
           </a:p>
         </p:txBody>
@@ -26695,7 +26711,7 @@
                 </a:solidFill>
                 <a:latin typeface="Consolas"/>
               </a:rPr>
-              <a:t>M4 · GEMINI CLI</a:t>
+              <a:t>M4 · ANTIGRAVITY CLI</a:t>
             </a:r>
           </a:p>
         </p:txBody>
@@ -27310,7 +27326,7 @@
                 </a:solidFill>
                 <a:latin typeface="Microsoft JhengHei"/>
               </a:rPr>
-              <a:t>Antigravity</a:t>
+              <a:t>Antigravity 桌面版</a:t>
             </a:r>
           </a:p>
         </p:txBody>
@@ -27567,7 +27583,7 @@
                 </a:solidFill>
                 <a:latin typeface="Microsoft JhengHei"/>
               </a:rPr>
-              <a:t>Gemini CLI</a:t>
+              <a:t>Antigravity CLI</a:t>
             </a:r>
           </a:p>
         </p:txBody>
@@ -28234,7 +28250,7 @@
                 </a:solidFill>
                 <a:latin typeface="Consolas"/>
               </a:rPr>
-              <a:t>gemini "hello"</a:t>
+              <a:t>agy "hello"</a:t>
             </a:r>
           </a:p>
           <a:p>
@@ -28250,7 +28266,7 @@
                 </a:solidFill>
                 <a:latin typeface="Consolas"/>
               </a:rPr>
-              <a:t>gemini "把這句翻成英文：今天天氣真好"</a:t>
+              <a:t>agy "把這句翻成英文：今天天氣真好"</a:t>
             </a:r>
           </a:p>
           <a:p>
@@ -28266,7 +28282,7 @@
                 </a:solidFill>
                 <a:latin typeface="Consolas"/>
               </a:rPr>
-              <a:t>cat news.txt | gemini "用三句話摘要"</a:t>
+              <a:t>cat news.txt | agy "用三句話摘要"</a:t>
             </a:r>
           </a:p>
         </p:txBody>
@@ -28340,7 +28356,7 @@
                 </a:solidFill>
                 <a:latin typeface="Consolas"/>
               </a:rPr>
-              <a:t>M4 · GEMINI CLI</a:t>
+              <a:t>M4 · ANTIGRAVITY CLI</a:t>
             </a:r>
           </a:p>
         </p:txBody>
@@ -28784,7 +28800,7 @@
                 </a:solidFill>
                 <a:latin typeface="Microsoft JhengHei"/>
               </a:rPr>
-              <a:t>丟進 Antigravity</a:t>
+              <a:t>丟進 Antigravity 桌面版</a:t>
             </a:r>
           </a:p>
         </p:txBody>
@@ -28936,7 +28952,7 @@
                 </a:solidFill>
                 <a:latin typeface="Microsoft JhengHei"/>
               </a:rPr>
-              <a:t>打進 Gemini CLI</a:t>
+              <a:t>打進 Antigravity CLI</a:t>
             </a:r>
           </a:p>
         </p:txBody>
@@ -29162,7 +29178,7 @@
                 </a:solidFill>
                 <a:latin typeface="Consolas"/>
               </a:rPr>
-              <a:t>M4 · GEMINI CLI</a:t>
+              <a:t>M4 · ANTIGRAVITY CLI</a:t>
             </a:r>
           </a:p>
         </p:txBody>
@@ -29417,7 +29433,7 @@
                 </a:solidFill>
                 <a:latin typeface="Consolas"/>
               </a:rPr>
-              <a:t>gemini "幫我把這句中文翻成英文：你好嗎"</a:t>
+              <a:t>agy "幫我把這句中文翻成英文：你好嗎"</a:t>
             </a:r>
           </a:p>
           <a:p>
@@ -29465,7 +29481,7 @@
                 </a:solidFill>
                 <a:latin typeface="Consolas"/>
               </a:rPr>
-              <a:t>cat news.txt | gemini "用三句話摘要"</a:t>
+              <a:t>cat news.txt | agy "用三句話摘要"</a:t>
             </a:r>
           </a:p>
           <a:p>
@@ -29513,7 +29529,7 @@
                 </a:solidFill>
                 <a:latin typeface="Consolas"/>
               </a:rPr>
-              <a:t>gemini "這段 CSV 轉成 JSON" &lt; data.csv &gt; data.json</a:t>
+              <a:t>agy "這段 CSV 轉成 JSON" &lt; data.csv &gt; data.json</a:t>
             </a:r>
           </a:p>
           <a:p>
@@ -29561,7 +29577,7 @@
                 </a:solidFill>
                 <a:latin typeface="Consolas"/>
               </a:rPr>
-              <a:t>gemini "你是編輯(R)，用五要格式(K)摘要：$(cat input.txt)"</a:t>
+              <a:t>agy "你是編輯(R)，用 STRIKE 格式(K)摘要：$(cat input.txt)"</a:t>
             </a:r>
           </a:p>
           <a:p>
@@ -29609,7 +29625,7 @@
                 </a:solidFill>
                 <a:latin typeface="Consolas"/>
               </a:rPr>
-              <a:t>cat news.txt | gemini "摘要" | gemini "翻成英文"</a:t>
+              <a:t>cat news.txt | agy "摘要" | agy "翻成英文"</a:t>
             </a:r>
           </a:p>
           <a:p>
@@ -29641,7 +29657,7 @@
                 </a:solidFill>
                 <a:latin typeface="Consolas"/>
               </a:rPr>
-              <a:t># 進階：互動模式</a:t>
+              <a:t># 進階：互動模式（TUI）</a:t>
             </a:r>
           </a:p>
           <a:p>
@@ -29657,7 +29673,7 @@
                 </a:solidFill>
                 <a:latin typeface="Consolas"/>
               </a:rPr>
-              <a:t>gemini</a:t>
+              <a:t>agy</a:t>
             </a:r>
           </a:p>
         </p:txBody>
@@ -29731,7 +29747,7 @@
                 </a:solidFill>
                 <a:latin typeface="Consolas"/>
               </a:rPr>
-              <a:t>M4 · GEMINI CLI</a:t>
+              <a:t>M4 · ANTIGRAVITY CLI</a:t>
             </a:r>
           </a:p>
         </p:txBody>
@@ -30436,7 +30452,7 @@
                 </a:solidFill>
                 <a:latin typeface="Consolas"/>
               </a:rPr>
-              <a:t>M4 · GEMINI CLI</a:t>
+              <a:t>M4 · ANTIGRAVITY CLI</a:t>
             </a:r>
           </a:p>
         </p:txBody>
@@ -30576,7 +30592,7 @@
                 </a:solidFill>
                 <a:latin typeface="Consolas"/>
               </a:rPr>
-              <a:t>M4 · GEMINI.MD — PROJECT MEMORY</a:t>
+              <a:t>M4 · AGENTS.MD — PROJECT MEMORY</a:t>
             </a:r>
           </a:p>
         </p:txBody>
@@ -30615,7 +30631,7 @@
                 </a:solidFill>
                 <a:latin typeface="Consolas"/>
               </a:rPr>
-              <a:t>GEMINI.md</a:t>
+              <a:t>AGENTS.md</a:t>
             </a:r>
           </a:p>
         </p:txBody>
@@ -30648,13 +30664,13 @@
               </a:lnSpc>
             </a:pPr>
             <a:r>
-              <a:rPr sz="1800" b="0" spc="-20">
+              <a:rPr sz="1600" b="0" spc="-20">
                 <a:solidFill>
                   <a:srgbClr val="8A8A8A"/>
                 </a:solidFill>
                 <a:latin typeface="Microsoft JhengHei"/>
               </a:rPr>
-              <a:t>給 agent 一份「公司守則」。每次開工自動讀。</a:t>
+              <a:t>給 agent 一份「公司守則」。每次開工自動讀。業界共識：Antigravity / Cursor / OpenAI Codex 都認。</a:t>
             </a:r>
           </a:p>
         </p:txBody>
@@ -30833,7 +30849,7 @@
                 </a:solidFill>
                 <a:latin typeface="Consolas"/>
               </a:rPr>
-              <a:t>兩個層級（Gemini CLI 都吃）：</a:t>
+              <a:t>兩個層級（Antigravity CLI 都吃）：</a:t>
             </a:r>
           </a:p>
         </p:txBody>
@@ -30887,13 +30903,13 @@
               </a:lnSpc>
             </a:pPr>
             <a:r>
-              <a:rPr sz="1400">
+              <a:rPr sz="1300">
                 <a:solidFill>
                   <a:srgbClr val="111111"/>
                 </a:solidFill>
                 <a:latin typeface="Consolas"/>
               </a:rPr>
-              <a:t>~/.gemini/GEMINI.md   = 全域（所有專案都套用）</a:t>
+              <a:t>~/.gemini/antigravity-cli/AGENTS.md   = 全域（過渡期沿用 .gemini/ 路徑）</a:t>
             </a:r>
           </a:p>
           <a:p>
@@ -30903,13 +30919,13 @@
               </a:lnSpc>
             </a:pPr>
             <a:r>
-              <a:rPr sz="1400">
+              <a:rPr sz="1300">
                 <a:solidFill>
                   <a:srgbClr val="111111"/>
                 </a:solidFill>
                 <a:latin typeface="Consolas"/>
               </a:rPr>
-              <a:t>./GEMINI.md           = 這個專案專用</a:t>
+              <a:t>./AGENTS.md                           = 這個專案專用</a:t>
             </a:r>
           </a:p>
         </p:txBody>
@@ -30983,7 +30999,7 @@
                 </a:solidFill>
                 <a:latin typeface="Consolas"/>
               </a:rPr>
-              <a:t>M4 · GEMINI CLI</a:t>
+              <a:t>M4 · ANTIGRAVITY CLI</a:t>
             </a:r>
           </a:p>
         </p:txBody>
@@ -31261,7 +31277,7 @@
                 </a:solidFill>
                 <a:latin typeface="Consolas"/>
               </a:rPr>
-              <a:t>cat news.txt | gemini "摘要"</a:t>
+              <a:t>cat news.txt | agy "摘要"</a:t>
             </a:r>
           </a:p>
         </p:txBody>
@@ -31360,7 +31376,7 @@
                 </a:solidFill>
                 <a:latin typeface="Consolas"/>
               </a:rPr>
-              <a:t>gemini "@news.txt 幫我摘要"</a:t>
+              <a:t>agy "@news.txt 幫我摘要"</a:t>
             </a:r>
           </a:p>
         </p:txBody>
@@ -31533,7 +31549,7 @@
                 </a:solidFill>
                 <a:latin typeface="Consolas"/>
               </a:rPr>
-              <a:t>gemini "@README.md @src/main.py 解釋這個程式怎麼跑"</a:t>
+              <a:t>agy "@README.md @src/main.py 解釋這個程式怎麼跑"</a:t>
             </a:r>
           </a:p>
         </p:txBody>
@@ -31607,7 +31623,7 @@
                 </a:solidFill>
                 <a:latin typeface="Consolas"/>
               </a:rPr>
-              <a:t>M4 · GEMINI CLI</a:t>
+              <a:t>M4 · ANTIGRAVITY CLI</a:t>
             </a:r>
           </a:p>
         </p:txBody>
@@ -31825,7 +31841,7 @@
                 </a:solidFill>
                 <a:latin typeface="Microsoft JhengHei"/>
               </a:rPr>
-              <a:t>Gemini CLI 不只會聊天，預設帶這些工具：</a:t>
+              <a:t>Antigravity CLI 不只會聊天，預設帶這些工具：</a:t>
             </a:r>
           </a:p>
         </p:txBody>
@@ -32250,7 +32266,7 @@
                 </a:solidFill>
                 <a:latin typeface="Microsoft JhengHei"/>
               </a:rPr>
-              <a:t>預設模式：每步都確認  ← 初學者請用這個</a:t>
+              <a:t>首次啟動：逐資料夾信任授權  ← 只信你自己的工作區</a:t>
             </a:r>
           </a:p>
         </p:txBody>
@@ -32285,11 +32301,11 @@
             <a:r>
               <a:rPr sz="1500" b="0" spc="-20">
                 <a:solidFill>
-                  <a:srgbClr val="B45309"/>
-                </a:solidFill>
-                <a:latin typeface="Consolas"/>
-              </a:rPr>
-              <a:t>--yolo 模式：不問直接做  ← demo 用，別在重要專案開</a:t>
+                  <a:srgbClr val="156B4A"/>
+                </a:solidFill>
+                <a:latin typeface="Microsoft JhengHei"/>
+              </a:rPr>
+              <a:t>每次動手：先問你「可以嗎？」  ← 確認模式 = 你的保護傘</a:t>
             </a:r>
           </a:p>
         </p:txBody>
@@ -32363,7 +32379,7 @@
                 </a:solidFill>
                 <a:latin typeface="Consolas"/>
               </a:rPr>
-              <a:t>M4 · GEMINI CLI</a:t>
+              <a:t>M4 · ANTIGRAVITY CLI</a:t>
             </a:r>
           </a:p>
         </p:txBody>
@@ -33119,7 +33135,7 @@
                 </a:solidFill>
                 <a:latin typeface="Consolas"/>
               </a:rPr>
-              <a:t>M4 · GEMINI CLI</a:t>
+              <a:t>M4 · ANTIGRAVITY CLI</a:t>
             </a:r>
           </a:p>
         </p:txBody>
@@ -33298,7 +33314,7 @@
                 </a:solidFill>
                 <a:latin typeface="Microsoft JhengHei"/>
               </a:rPr>
-              <a:t>你學的不是 Gemini CLI，是通用技能</a:t>
+              <a:t>你學的不是 Antigravity CLI，是通用技能</a:t>
             </a:r>
           </a:p>
         </p:txBody>
@@ -33428,7 +33444,7 @@
                           </a:solidFill>
                           <a:latin typeface="Microsoft JhengHei"/>
                         </a:rPr>
-                        <a:t>Antigravity</a:t>
+                        <a:t>Antigravity 桌面</a:t>
                       </a:r>
                     </a:p>
                   </a:txBody>
@@ -33475,7 +33491,7 @@
                           </a:solidFill>
                           <a:latin typeface="Microsoft JhengHei"/>
                         </a:rPr>
-                        <a:t>Gemini CLI</a:t>
+                        <a:t>Antigravity CLI</a:t>
                       </a:r>
                     </a:p>
                   </a:txBody>
@@ -33712,7 +33728,7 @@
                           </a:solidFill>
                           <a:latin typeface="Consolas"/>
                         </a:rPr>
-                        <a:t>AGENTS.md *</a:t>
+                        <a:t>AGENTS.md</a:t>
                       </a:r>
                     </a:p>
                   </a:txBody>
@@ -33759,13 +33775,13 @@
                           </a:solidFill>
                           <a:latin typeface="Consolas"/>
                         </a:rPr>
-                        <a:t>GEMINI.md</a:t>
+                        <a:t>AGENTS.md ⭐</a:t>
                       </a:r>
                     </a:p>
                   </a:txBody>
                   <a:tcPr marL="73152" marR="73152" marT="45720" marB="45720" anchor="ctr">
                     <a:solidFill>
-                      <a:srgbClr val="FFFFFF"/>
+                      <a:srgbClr val="FEF7E6"/>
                     </a:solidFill>
                     <a:lnL w="9525" cap="flat" cmpd="sng" algn="ctr">
                       <a:solidFill>
@@ -34778,7 +34794,7 @@
                 </a:solidFill>
                 <a:latin typeface="Microsoft JhengHei"/>
               </a:rPr>
-              <a:t>*  Antigravity 與 Gemini CLI 共用 ~/.gemini/GEMINI.md 做全域設定（同一家人）</a:t>
+              <a:t>⭐  Antigravity CLI 用 AGENTS.md 取代舊版 GEMINI.md（agy plugin import gemini 一鍵搬）</a:t>
             </a:r>
           </a:p>
         </p:txBody>
@@ -34852,7 +34868,7 @@
                 </a:solidFill>
                 <a:latin typeface="Microsoft JhengHei"/>
               </a:rPr>
-              <a:t>🟡  AGENTS.md 是 2026 新興的「跨工具通用」格式</a:t>
+              <a:t>🟡  AGENTS.md 是 2026 業界共識的「跨工具通用」格式</a:t>
             </a:r>
           </a:p>
         </p:txBody>
@@ -34891,7 +34907,7 @@
                 </a:solidFill>
                 <a:latin typeface="Microsoft JhengHei"/>
               </a:rPr>
-              <a:t>    Cursor 與 Antigravity 都認得它，最值得學</a:t>
+              <a:t>    Antigravity / Cursor / OpenAI Codex 都認，最值得學</a:t>
             </a:r>
           </a:p>
         </p:txBody>
@@ -34965,7 +34981,7 @@
                 </a:solidFill>
                 <a:latin typeface="Consolas"/>
               </a:rPr>
-              <a:t>M4 · GEMINI CLI</a:t>
+              <a:t>M4 · ANTIGRAVITY CLI</a:t>
             </a:r>
           </a:p>
         </p:txBody>
@@ -35233,7 +35249,7 @@
                 </a:solidFill>
                 <a:latin typeface="Microsoft JhengHei"/>
               </a:rPr>
-              <a:t>必做（5 min）：在你的專案根目錄建一份 GEMINI.md（5 行就好）</a:t>
+              <a:t>必做（5 min）：在你的專案根目錄建一份 AGENTS.md（5 行就好）</a:t>
             </a:r>
           </a:p>
         </p:txBody>
@@ -35350,7 +35366,7 @@
                 </a:solidFill>
                 <a:latin typeface="Microsoft JhengHei"/>
               </a:rPr>
-              <a:t>A.   把核心功能寫成一行指令     例：summarize.sh news.txt</a:t>
+              <a:t>A.   把核心功能寫成一行 agy 指令     例：agy "summarize @news.txt &gt; out.md"</a:t>
             </a:r>
           </a:p>
         </p:txBody>
@@ -35389,7 +35405,7 @@
                 </a:solidFill>
                 <a:latin typeface="Microsoft JhengHei"/>
               </a:rPr>
-              <a:t>B.   寫腳本自動產測試資料        例：gen_data.sh 10</a:t>
+              <a:t>B.   寫腳本自動產測試資料           例：agy --headless "產 10 筆假資料 JSON"</a:t>
             </a:r>
           </a:p>
         </p:txBody>
@@ -35428,7 +35444,7 @@
                 </a:solidFill>
                 <a:latin typeface="Microsoft JhengHei"/>
               </a:rPr>
-              <a:t>C.   寫一個「每天跑一次」的小工具（不實際排程）</a:t>
+              <a:t>C.   寫一個「每天跑一次」的小工具（先手動跑；可後續用 Scheduled Tasks 排程）</a:t>
             </a:r>
           </a:p>
         </p:txBody>
@@ -35615,7 +35631,7 @@
                 </a:solidFill>
                 <a:latin typeface="Consolas"/>
               </a:rPr>
-              <a:t>M4 · GEMINI CLI</a:t>
+              <a:t>M4 · ANTIGRAVITY CLI</a:t>
             </a:r>
           </a:p>
         </p:txBody>
@@ -36554,7 +36570,7 @@
                 </a:solidFill>
                 <a:latin typeface="Microsoft JhengHei"/>
               </a:rPr>
-              <a:t>Gemini CLI</a:t>
+              <a:t>Antigravity CLI（agy）</a:t>
             </a:r>
           </a:p>
         </p:txBody>
@@ -37382,7 +37398,7 @@
                 </a:solidFill>
                 <a:latin typeface="Consolas"/>
               </a:rPr>
-              <a:t>├─  做有介面的東西                   →   Antigravity</a:t>
+              <a:t>├─  做有介面的東西                   →   Antigravity 桌面版</a:t>
             </a:r>
           </a:p>
           <a:p>
@@ -37398,7 +37414,7 @@
                 </a:solidFill>
                 <a:latin typeface="Consolas"/>
               </a:rPr>
-              <a:t>├─  把重複的事自動化                 →   Gemini CLI</a:t>
+              <a:t>├─  把重複的事自動化                 →   Antigravity CLI（agy）</a:t>
             </a:r>
           </a:p>
           <a:p>
@@ -37414,7 +37430,7 @@
                 </a:solidFill>
                 <a:latin typeface="Consolas"/>
               </a:rPr>
-              <a:t>├─  超大專案 / 多人協作              →   Antigravity（多 agent）</a:t>
+              <a:t>├─  超大專案 / 多人協作              →   Antigravity 桌面版（多 agent）</a:t>
             </a:r>
           </a:p>
           <a:p>
@@ -37578,7 +37594,7 @@
                 </a:solidFill>
                 <a:latin typeface="Consolas"/>
               </a:rPr>
-              <a:t>M4 · GEMINI CLI</a:t>
+              <a:t>M4 · ANTIGRAVITY CLI</a:t>
             </a:r>
           </a:p>
         </p:txBody>
@@ -37905,7 +37921,7 @@
                 </a:solidFill>
                 <a:latin typeface="Microsoft JhengHei"/>
               </a:rPr>
-              <a:t>·  Gemini CLI = AI Studio 的無介面版</a:t>
+              <a:t>·  Antigravity CLI（agy）= AI Studio 的無介面版 + 桌面版的腳本版</a:t>
             </a:r>
           </a:p>
         </p:txBody>
@@ -38053,7 +38069,7 @@
                 </a:solidFill>
                 <a:latin typeface="Microsoft JhengHei"/>
               </a:rPr>
-              <a:t>·  CLI 是你之後做「每天自動跑」的基礎</a:t>
+              <a:t>·  AGENTS.md 是業界共識，換工具不換腦袋</a:t>
             </a:r>
           </a:p>
         </p:txBody>
@@ -38240,7 +38256,7 @@
                 </a:solidFill>
                 <a:latin typeface="Consolas"/>
               </a:rPr>
-              <a:t>M4 · GEMINI CLI</a:t>
+              <a:t>M4 · ANTIGRAVITY CLI</a:t>
             </a:r>
           </a:p>
         </p:txBody>
@@ -41576,7 +41592,7 @@
                 </a:solidFill>
                 <a:latin typeface="Microsoft JhengHei"/>
               </a:rPr>
-              <a:t>□  用 Gemini CLI 做一件以前手動的事</a:t>
+              <a:t>□  用 Antigravity CLI（agy）做一件以前手動的事</a:t>
             </a:r>
           </a:p>
         </p:txBody>
@@ -46359,7 +46375,7 @@
                 </a:solidFill>
                 <a:latin typeface="Consolas"/>
               </a:rPr>
-              <a:t>ANTIGRAVITY</a:t>
+              <a:t>ANTIGRAVITY 桌面版</a:t>
             </a:r>
           </a:p>
         </p:txBody>
@@ -46487,7 +46503,7 @@
                 </a:solidFill>
                 <a:latin typeface="Consolas"/>
               </a:rPr>
-              <a:t>GEMINI CLI</a:t>
+              <a:t>ANTIGRAVITY CLI</a:t>
             </a:r>
           </a:p>
         </p:txBody>
@@ -46526,7 +46542,7 @@
                 </a:solidFill>
                 <a:latin typeface="Microsoft JhengHei"/>
               </a:rPr>
-              <a:t>cat news.txt | gemini "摘要" | gemini "翻成英文"（L3 鏈式）</a:t>
+              <a:t>cat news.txt | agy "摘要" | agy "翻成英文"（L3 鏈式）</a:t>
             </a:r>
           </a:p>
         </p:txBody>
@@ -46639,7 +46655,7 @@
                 </a:solidFill>
                 <a:latin typeface="Microsoft JhengHei"/>
               </a:rPr>
-              <a:t>教案 S16、S33 現成材料；Gemini 免費純文字額度綽綽有餘；L3 鏈式天然銜接 M4 CLI；30 人同時跑無壓力。</a:t>
+              <a:t>教案 S16、S33 現成材料；Gemini API 免費純文字額度綽綽有餘；L3 鏈式天然銜接 M4 CLI；30 人同時跑無壓力。</a:t>
             </a:r>
           </a:p>
         </p:txBody>
@@ -47148,7 +47164,7 @@
                 </a:solidFill>
                 <a:latin typeface="Consolas"/>
               </a:rPr>
-              <a:t>ANTIGRAVITY</a:t>
+              <a:t>ANTIGRAVITY 桌面版</a:t>
             </a:r>
           </a:p>
         </p:txBody>
@@ -47276,7 +47292,7 @@
                 </a:solidFill>
                 <a:latin typeface="Consolas"/>
               </a:rPr>
-              <a:t>GEMINI CLI</a:t>
+              <a:t>ANTIGRAVITY CLI</a:t>
             </a:r>
           </a:p>
         </p:txBody>
@@ -47315,7 +47331,7 @@
                 </a:solidFill>
                 <a:latin typeface="Microsoft JhengHei"/>
               </a:rPr>
-              <a:t>批次處理多場會議：for f in meetings/*.txt; do gemini &lt; $f; done</a:t>
+              <a:t>批次處理多場會議：for f in meetings/*.txt; do agy &lt; $f; done</a:t>
             </a:r>
           </a:p>
         </p:txBody>
@@ -47937,7 +47953,7 @@
                 </a:solidFill>
                 <a:latin typeface="Consolas"/>
               </a:rPr>
-              <a:t>ANTIGRAVITY</a:t>
+              <a:t>ANTIGRAVITY 桌面版</a:t>
             </a:r>
           </a:p>
         </p:txBody>
@@ -48065,7 +48081,7 @@
                 </a:solidFill>
                 <a:latin typeface="Consolas"/>
               </a:rPr>
-              <a:t>GEMINI CLI</a:t>
+              <a:t>ANTIGRAVITY CLI</a:t>
             </a:r>
           </a:p>
         </p:txBody>
@@ -48104,7 +48120,7 @@
                 </a:solidFill>
                 <a:latin typeface="Microsoft JhengHei"/>
               </a:rPr>
-              <a:t>gemini "今晚煮什麼" --pantry fridge.txt（可定時每天 17:00 跑）</a:t>
+              <a:t>agy "今晚煮什麼 @fridge.txt"（可用 Scheduled Tasks 每天 17:00 跑）</a:t>
             </a:r>
           </a:p>
         </p:txBody>

</xml_diff>

<commit_message>
refactor(antigravity-template): MVP vibe coding 瘦身 + 補學員必踩雷點
依「沒寫過程式的人 8 小時做 MVP」視角審視後的改進：

P1 補學員會踩的兩處雷點：
- M4 簡報 S44 加 /memory show + /memory refresh debug 流程（AI 沒讀到規則時 90% 是這個解決）
- M4 簡報 S46 從「雙重保險」升級為「三層保險」（事前/事中/事後），事後層補 /restore checkpoint 救命繩
- teaching_plan.md M4 對應段落補強 demo 指示

P2 Linus 式瘦身（移除過頭設計）：
- AGENTS.md 砍 4.7 Dynamic Subagents 整段（初學者用不到，提了反而引入新名詞干擾）
- .agents/skills/ 從 6 個瘦身到 3 個核心（vibe:plan / explain-code / check-key），
  砍掉 test / explain / git:commit（MVP 階段用不到，學員記不住）
- 被砍 3 個 skill 改為 SKILLS.md「範例庫」段，學員需要時自行複製

文件結構同步：
- .agents/skills/README.md + template README.md 更新檔案樹與「卡住時看哪裡」表
- 在「卡住時看哪裡」表補上 /restore 與 /memory show 兩條救命繩
- 區分 prompts/start-project.md（全文模板）vs /vibe:plan（CLI slash）的使用時機
- vibe_coding_workshop.pptx 重新產出（64 張）

Co-Authored-By: Claude Opus 4.7 (1M context) <noreply@anthropic.com>
</commit_message>
<xml_diff>
--- a/class_plan/vibe_coding_workshop.pptx
+++ b/class_plan/vibe_coding_workshop.pptx
@@ -30684,7 +30684,7 @@
         <p:spPr>
           <a:xfrm>
             <a:off x="731520" y="2606040"/>
-            <a:ext cx="10698480" cy="2011680"/>
+            <a:ext cx="10698480" cy="1874519"/>
           </a:xfrm>
           <a:prstGeom prst="roundRect">
             <a:avLst>
@@ -30823,27 +30823,27 @@
         </p:nvSpPr>
         <p:spPr>
           <a:xfrm>
-            <a:off x="731520" y="4800600"/>
-            <a:ext cx="10698480" cy="365760"/>
-          </a:xfrm>
-          <a:prstGeom prst="rect">
-            <a:avLst/>
-          </a:prstGeom>
-          <a:noFill/>
-        </p:spPr>
-        <p:txBody>
-          <a:bodyPr wrap="square" lIns="45720" rIns="45720" tIns="18288" bIns="18288" anchor="t">
-            <a:spAutoFit/>
-          </a:bodyPr>
-          <a:lstStyle/>
-          <a:p>
-            <a:pPr algn="l">
-              <a:lnSpc>
-                <a:spcPct val="135000"/>
-              </a:lnSpc>
-            </a:pPr>
-            <a:r>
-              <a:rPr sz="1300" b="0" spc="150">
+            <a:off x="731520" y="4617720"/>
+            <a:ext cx="10698480" cy="320040"/>
+          </a:xfrm>
+          <a:prstGeom prst="rect">
+            <a:avLst/>
+          </a:prstGeom>
+          <a:noFill/>
+        </p:spPr>
+        <p:txBody>
+          <a:bodyPr wrap="square" lIns="45720" rIns="45720" tIns="18288" bIns="18288" anchor="t">
+            <a:spAutoFit/>
+          </a:bodyPr>
+          <a:lstStyle/>
+          <a:p>
+            <a:pPr algn="l">
+              <a:lnSpc>
+                <a:spcPct val="135000"/>
+              </a:lnSpc>
+            </a:pPr>
+            <a:r>
+              <a:rPr sz="1200" b="0" spc="150">
                 <a:solidFill>
                   <a:srgbClr val="8A8A8A"/>
                 </a:solidFill>
@@ -30862,8 +30862,8 @@
         </p:nvSpPr>
         <p:spPr>
           <a:xfrm>
-            <a:off x="731520" y="5166360"/>
-            <a:ext cx="10698480" cy="1005840"/>
+            <a:off x="731520" y="4937760"/>
+            <a:ext cx="10698480" cy="822960"/>
           </a:xfrm>
           <a:prstGeom prst="roundRect">
             <a:avLst>
@@ -30903,7 +30903,7 @@
               </a:lnSpc>
             </a:pPr>
             <a:r>
-              <a:rPr sz="1300">
+              <a:rPr sz="1200">
                 <a:solidFill>
                   <a:srgbClr val="111111"/>
                 </a:solidFill>
@@ -30919,7 +30919,7 @@
               </a:lnSpc>
             </a:pPr>
             <a:r>
-              <a:rPr sz="1300">
+              <a:rPr sz="1200">
                 <a:solidFill>
                   <a:srgbClr val="111111"/>
                 </a:solidFill>
@@ -30938,8 +30938,8 @@
         </p:nvCxnSpPr>
         <p:spPr>
           <a:xfrm>
-            <a:off x="548640" y="6446520"/>
-            <a:ext cx="11091672" cy="0"/>
+            <a:off x="731520" y="5852160"/>
+            <a:ext cx="10698480" cy="0"/>
           </a:xfrm>
           <a:prstGeom prst="line">
             <a:avLst/>
@@ -30973,6 +30973,80 @@
         </p:nvSpPr>
         <p:spPr>
           <a:xfrm>
+            <a:off x="731520" y="5943600"/>
+            <a:ext cx="10698480" cy="411480"/>
+          </a:xfrm>
+          <a:prstGeom prst="rect">
+            <a:avLst/>
+          </a:prstGeom>
+          <a:noFill/>
+        </p:spPr>
+        <p:txBody>
+          <a:bodyPr wrap="square" lIns="45720" rIns="45720" tIns="18288" bIns="18288" anchor="t">
+            <a:spAutoFit/>
+          </a:bodyPr>
+          <a:lstStyle/>
+          <a:p>
+            <a:pPr algn="l">
+              <a:lnSpc>
+                <a:spcPct val="135000"/>
+              </a:lnSpc>
+            </a:pPr>
+            <a:r>
+              <a:rPr sz="1300" b="0" spc="-20">
+                <a:solidFill>
+                  <a:srgbClr val="B45309"/>
+                </a:solidFill>
+                <a:latin typeface="Consolas"/>
+              </a:rPr>
+              <a:t>🔧  Debug：AI 沒讀到規則？打 /memory show 看實際載入；改完 AGENTS.md 打 /memory refresh</a:t>
+            </a:r>
+          </a:p>
+        </p:txBody>
+      </p:sp>
+      <p:cxnSp>
+        <p:nvCxnSpPr>
+          <p:cNvPr id="11" name="Connector 10"/>
+          <p:cNvCxnSpPr/>
+          <p:nvPr/>
+        </p:nvCxnSpPr>
+        <p:spPr>
+          <a:xfrm>
+            <a:off x="548640" y="6446520"/>
+            <a:ext cx="11091672" cy="0"/>
+          </a:xfrm>
+          <a:prstGeom prst="line">
+            <a:avLst/>
+          </a:prstGeom>
+          <a:ln w="6350">
+            <a:solidFill>
+              <a:srgbClr val="E5E5E5"/>
+            </a:solidFill>
+          </a:ln>
+        </p:spPr>
+        <p:style>
+          <a:lnRef idx="2">
+            <a:schemeClr val="accent1"/>
+          </a:lnRef>
+          <a:fillRef idx="0">
+            <a:schemeClr val="accent1"/>
+          </a:fillRef>
+          <a:effectRef idx="1">
+            <a:schemeClr val="accent1"/>
+          </a:effectRef>
+          <a:fontRef idx="minor">
+            <a:schemeClr val="tx1"/>
+          </a:fontRef>
+        </p:style>
+      </p:cxnSp>
+      <p:sp>
+        <p:nvSpPr>
+          <p:cNvPr id="12" name="TextBox 11"/>
+          <p:cNvSpPr txBox="1"/>
+          <p:nvPr/>
+        </p:nvSpPr>
+        <p:spPr>
+          <a:xfrm>
             <a:off x="548640" y="6537960"/>
             <a:ext cx="7315200" cy="274320"/>
           </a:xfrm>
@@ -31006,7 +31080,7 @@
       </p:sp>
       <p:sp>
         <p:nvSpPr>
-          <p:cNvPr id="11" name="TextBox 10"/>
+          <p:cNvPr id="13" name="TextBox 12"/>
           <p:cNvSpPr txBox="1"/>
           <p:nvPr/>
         </p:nvSpPr>
@@ -31763,7 +31837,7 @@
                 </a:solidFill>
                 <a:latin typeface="Consolas"/>
               </a:rPr>
-              <a:t>M4 · BUILT-IN TOOLS &amp; SAFETY</a:t>
+              <a:t>M4 · BUILT-IN TOOLS &amp; THREE-LAYER SAFETY</a:t>
             </a:r>
           </a:p>
         </p:txBody>
@@ -31802,7 +31876,7 @@
                 </a:solidFill>
                 <a:latin typeface="Microsoft JhengHei"/>
               </a:rPr>
-              <a:t>內建工具 + 安全模式</a:t>
+              <a:t>內建工具 + 三層保險</a:t>
             </a:r>
           </a:p>
         </p:txBody>
@@ -31815,8 +31889,86 @@
         </p:nvSpPr>
         <p:spPr>
           <a:xfrm>
-            <a:off x="731520" y="1965960"/>
-            <a:ext cx="10698480" cy="457200"/>
+            <a:off x="731520" y="1874519"/>
+            <a:ext cx="10698480" cy="365760"/>
+          </a:xfrm>
+          <a:prstGeom prst="rect">
+            <a:avLst/>
+          </a:prstGeom>
+          <a:noFill/>
+        </p:spPr>
+        <p:txBody>
+          <a:bodyPr wrap="square" lIns="45720" rIns="45720" tIns="18288" bIns="18288" anchor="t">
+            <a:spAutoFit/>
+          </a:bodyPr>
+          <a:lstStyle/>
+          <a:p>
+            <a:pPr algn="l">
+              <a:lnSpc>
+                <a:spcPct val="135000"/>
+              </a:lnSpc>
+            </a:pPr>
+            <a:r>
+              <a:rPr sz="1500" b="0" spc="-20">
+                <a:solidFill>
+                  <a:srgbClr val="8A8A8A"/>
+                </a:solidFill>
+                <a:latin typeface="Microsoft JhengHei"/>
+              </a:rPr>
+              <a:t>Antigravity CLI 不只會聊天，預設帶這些工具：</a:t>
+            </a:r>
+          </a:p>
+        </p:txBody>
+      </p:sp>
+      <p:sp>
+        <p:nvSpPr>
+          <p:cNvPr id="6" name="TextBox 5"/>
+          <p:cNvSpPr txBox="1"/>
+          <p:nvPr/>
+        </p:nvSpPr>
+        <p:spPr>
+          <a:xfrm>
+            <a:off x="914400" y="2423160"/>
+            <a:ext cx="5029200" cy="320040"/>
+          </a:xfrm>
+          <a:prstGeom prst="rect">
+            <a:avLst/>
+          </a:prstGeom>
+          <a:noFill/>
+        </p:spPr>
+        <p:txBody>
+          <a:bodyPr wrap="square" lIns="45720" rIns="45720" tIns="18288" bIns="18288" anchor="t">
+            <a:spAutoFit/>
+          </a:bodyPr>
+          <a:lstStyle/>
+          <a:p>
+            <a:pPr algn="l">
+              <a:lnSpc>
+                <a:spcPct val="135000"/>
+              </a:lnSpc>
+            </a:pPr>
+            <a:r>
+              <a:rPr sz="1600" b="1" spc="-20">
+                <a:solidFill>
+                  <a:srgbClr val="111111"/>
+                </a:solidFill>
+                <a:latin typeface="Consolas"/>
+              </a:rPr>
+              <a:t>📂  ReadFile / WriteFile</a:t>
+            </a:r>
+          </a:p>
+        </p:txBody>
+      </p:sp>
+      <p:sp>
+        <p:nvSpPr>
+          <p:cNvPr id="7" name="TextBox 6"/>
+          <p:cNvSpPr txBox="1"/>
+          <p:nvPr/>
+        </p:nvSpPr>
+        <p:spPr>
+          <a:xfrm>
+            <a:off x="6217920" y="2423160"/>
+            <a:ext cx="5212080" cy="320040"/>
           </a:xfrm>
           <a:prstGeom prst="rect">
             <a:avLst/>
@@ -31837,283 +31989,205 @@
             <a:r>
               <a:rPr sz="1600" b="0" spc="-20">
                 <a:solidFill>
-                  <a:srgbClr val="8A8A8A"/>
+                  <a:srgbClr val="3A3A3A"/>
                 </a:solidFill>
                 <a:latin typeface="Microsoft JhengHei"/>
               </a:rPr>
-              <a:t>Antigravity CLI 不只會聊天，預設帶這些工具：</a:t>
-            </a:r>
-          </a:p>
-        </p:txBody>
-      </p:sp>
-      <p:sp>
-        <p:nvSpPr>
-          <p:cNvPr id="6" name="TextBox 5"/>
-          <p:cNvSpPr txBox="1"/>
-          <p:nvPr/>
-        </p:nvSpPr>
-        <p:spPr>
-          <a:xfrm>
-            <a:off x="914400" y="2651760"/>
-            <a:ext cx="5029200" cy="365760"/>
-          </a:xfrm>
-          <a:prstGeom prst="rect">
-            <a:avLst/>
-          </a:prstGeom>
-          <a:noFill/>
-        </p:spPr>
-        <p:txBody>
-          <a:bodyPr wrap="square" lIns="45720" rIns="45720" tIns="18288" bIns="18288" anchor="t">
-            <a:spAutoFit/>
-          </a:bodyPr>
-          <a:lstStyle/>
-          <a:p>
-            <a:pPr algn="l">
-              <a:lnSpc>
-                <a:spcPct val="135000"/>
-              </a:lnSpc>
-            </a:pPr>
-            <a:r>
-              <a:rPr sz="1800" b="1" spc="-20">
+              <a:t>讀寫檔案</a:t>
+            </a:r>
+          </a:p>
+        </p:txBody>
+      </p:sp>
+      <p:sp>
+        <p:nvSpPr>
+          <p:cNvPr id="8" name="TextBox 7"/>
+          <p:cNvSpPr txBox="1"/>
+          <p:nvPr/>
+        </p:nvSpPr>
+        <p:spPr>
+          <a:xfrm>
+            <a:off x="914400" y="2807208"/>
+            <a:ext cx="5029200" cy="320040"/>
+          </a:xfrm>
+          <a:prstGeom prst="rect">
+            <a:avLst/>
+          </a:prstGeom>
+          <a:noFill/>
+        </p:spPr>
+        <p:txBody>
+          <a:bodyPr wrap="square" lIns="45720" rIns="45720" tIns="18288" bIns="18288" anchor="t">
+            <a:spAutoFit/>
+          </a:bodyPr>
+          <a:lstStyle/>
+          <a:p>
+            <a:pPr algn="l">
+              <a:lnSpc>
+                <a:spcPct val="135000"/>
+              </a:lnSpc>
+            </a:pPr>
+            <a:r>
+              <a:rPr sz="1600" b="1" spc="-20">
                 <a:solidFill>
                   <a:srgbClr val="111111"/>
                 </a:solidFill>
                 <a:latin typeface="Consolas"/>
               </a:rPr>
-              <a:t>📂  ReadFile / WriteFile</a:t>
-            </a:r>
-          </a:p>
-        </p:txBody>
-      </p:sp>
-      <p:sp>
-        <p:nvSpPr>
-          <p:cNvPr id="7" name="TextBox 6"/>
-          <p:cNvSpPr txBox="1"/>
-          <p:nvPr/>
-        </p:nvSpPr>
-        <p:spPr>
-          <a:xfrm>
-            <a:off x="6217920" y="2651760"/>
-            <a:ext cx="5212080" cy="365760"/>
-          </a:xfrm>
-          <a:prstGeom prst="rect">
-            <a:avLst/>
-          </a:prstGeom>
-          <a:noFill/>
-        </p:spPr>
-        <p:txBody>
-          <a:bodyPr wrap="square" lIns="45720" rIns="45720" tIns="18288" bIns="18288" anchor="t">
-            <a:spAutoFit/>
-          </a:bodyPr>
-          <a:lstStyle/>
-          <a:p>
-            <a:pPr algn="l">
-              <a:lnSpc>
-                <a:spcPct val="135000"/>
-              </a:lnSpc>
-            </a:pPr>
-            <a:r>
-              <a:rPr sz="1800" b="0" spc="-20">
+              <a:t>🐚  Shell</a:t>
+            </a:r>
+          </a:p>
+        </p:txBody>
+      </p:sp>
+      <p:sp>
+        <p:nvSpPr>
+          <p:cNvPr id="9" name="TextBox 8"/>
+          <p:cNvSpPr txBox="1"/>
+          <p:nvPr/>
+        </p:nvSpPr>
+        <p:spPr>
+          <a:xfrm>
+            <a:off x="6217920" y="2807208"/>
+            <a:ext cx="5212080" cy="320040"/>
+          </a:xfrm>
+          <a:prstGeom prst="rect">
+            <a:avLst/>
+          </a:prstGeom>
+          <a:noFill/>
+        </p:spPr>
+        <p:txBody>
+          <a:bodyPr wrap="square" lIns="45720" rIns="45720" tIns="18288" bIns="18288" anchor="t">
+            <a:spAutoFit/>
+          </a:bodyPr>
+          <a:lstStyle/>
+          <a:p>
+            <a:pPr algn="l">
+              <a:lnSpc>
+                <a:spcPct val="135000"/>
+              </a:lnSpc>
+            </a:pPr>
+            <a:r>
+              <a:rPr sz="1600" b="0" spc="-20">
                 <a:solidFill>
                   <a:srgbClr val="3A3A3A"/>
                 </a:solidFill>
                 <a:latin typeface="Microsoft JhengHei"/>
               </a:rPr>
-              <a:t>讀寫檔案</a:t>
-            </a:r>
-          </a:p>
-        </p:txBody>
-      </p:sp>
-      <p:sp>
-        <p:nvSpPr>
-          <p:cNvPr id="8" name="TextBox 7"/>
-          <p:cNvSpPr txBox="1"/>
-          <p:nvPr/>
-        </p:nvSpPr>
-        <p:spPr>
-          <a:xfrm>
-            <a:off x="914400" y="3108960"/>
-            <a:ext cx="5029200" cy="365760"/>
-          </a:xfrm>
-          <a:prstGeom prst="rect">
-            <a:avLst/>
-          </a:prstGeom>
-          <a:noFill/>
-        </p:spPr>
-        <p:txBody>
-          <a:bodyPr wrap="square" lIns="45720" rIns="45720" tIns="18288" bIns="18288" anchor="t">
-            <a:spAutoFit/>
-          </a:bodyPr>
-          <a:lstStyle/>
-          <a:p>
-            <a:pPr algn="l">
-              <a:lnSpc>
-                <a:spcPct val="135000"/>
-              </a:lnSpc>
-            </a:pPr>
-            <a:r>
-              <a:rPr sz="1800" b="1" spc="-20">
+              <a:t>跑指令</a:t>
+            </a:r>
+          </a:p>
+        </p:txBody>
+      </p:sp>
+      <p:sp>
+        <p:nvSpPr>
+          <p:cNvPr id="10" name="TextBox 9"/>
+          <p:cNvSpPr txBox="1"/>
+          <p:nvPr/>
+        </p:nvSpPr>
+        <p:spPr>
+          <a:xfrm>
+            <a:off x="914400" y="3191256"/>
+            <a:ext cx="5029200" cy="320040"/>
+          </a:xfrm>
+          <a:prstGeom prst="rect">
+            <a:avLst/>
+          </a:prstGeom>
+          <a:noFill/>
+        </p:spPr>
+        <p:txBody>
+          <a:bodyPr wrap="square" lIns="45720" rIns="45720" tIns="18288" bIns="18288" anchor="t">
+            <a:spAutoFit/>
+          </a:bodyPr>
+          <a:lstStyle/>
+          <a:p>
+            <a:pPr algn="l">
+              <a:lnSpc>
+                <a:spcPct val="135000"/>
+              </a:lnSpc>
+            </a:pPr>
+            <a:r>
+              <a:rPr sz="1600" b="1" spc="-20">
                 <a:solidFill>
                   <a:srgbClr val="111111"/>
                 </a:solidFill>
                 <a:latin typeface="Consolas"/>
               </a:rPr>
-              <a:t>🐚  Shell</a:t>
-            </a:r>
-          </a:p>
-        </p:txBody>
-      </p:sp>
-      <p:sp>
-        <p:nvSpPr>
-          <p:cNvPr id="9" name="TextBox 8"/>
-          <p:cNvSpPr txBox="1"/>
-          <p:nvPr/>
-        </p:nvSpPr>
-        <p:spPr>
-          <a:xfrm>
-            <a:off x="6217920" y="3108960"/>
-            <a:ext cx="5212080" cy="365760"/>
-          </a:xfrm>
-          <a:prstGeom prst="rect">
-            <a:avLst/>
-          </a:prstGeom>
-          <a:noFill/>
-        </p:spPr>
-        <p:txBody>
-          <a:bodyPr wrap="square" lIns="45720" rIns="45720" tIns="18288" bIns="18288" anchor="t">
-            <a:spAutoFit/>
-          </a:bodyPr>
-          <a:lstStyle/>
-          <a:p>
-            <a:pPr algn="l">
-              <a:lnSpc>
-                <a:spcPct val="135000"/>
-              </a:lnSpc>
-            </a:pPr>
-            <a:r>
-              <a:rPr sz="1800" b="0" spc="-20">
+              <a:t>🔍  GoogleSearch</a:t>
+            </a:r>
+          </a:p>
+        </p:txBody>
+      </p:sp>
+      <p:sp>
+        <p:nvSpPr>
+          <p:cNvPr id="11" name="TextBox 10"/>
+          <p:cNvSpPr txBox="1"/>
+          <p:nvPr/>
+        </p:nvSpPr>
+        <p:spPr>
+          <a:xfrm>
+            <a:off x="6217920" y="3191256"/>
+            <a:ext cx="5212080" cy="320040"/>
+          </a:xfrm>
+          <a:prstGeom prst="rect">
+            <a:avLst/>
+          </a:prstGeom>
+          <a:noFill/>
+        </p:spPr>
+        <p:txBody>
+          <a:bodyPr wrap="square" lIns="45720" rIns="45720" tIns="18288" bIns="18288" anchor="t">
+            <a:spAutoFit/>
+          </a:bodyPr>
+          <a:lstStyle/>
+          <a:p>
+            <a:pPr algn="l">
+              <a:lnSpc>
+                <a:spcPct val="135000"/>
+              </a:lnSpc>
+            </a:pPr>
+            <a:r>
+              <a:rPr sz="1600" b="0" spc="-20">
                 <a:solidFill>
                   <a:srgbClr val="3A3A3A"/>
                 </a:solidFill>
                 <a:latin typeface="Microsoft JhengHei"/>
               </a:rPr>
-              <a:t>跑指令</a:t>
-            </a:r>
-          </a:p>
-        </p:txBody>
-      </p:sp>
-      <p:sp>
-        <p:nvSpPr>
-          <p:cNvPr id="10" name="TextBox 9"/>
-          <p:cNvSpPr txBox="1"/>
-          <p:nvPr/>
-        </p:nvSpPr>
-        <p:spPr>
-          <a:xfrm>
-            <a:off x="914400" y="3566160"/>
-            <a:ext cx="5029200" cy="365760"/>
-          </a:xfrm>
-          <a:prstGeom prst="rect">
-            <a:avLst/>
-          </a:prstGeom>
-          <a:noFill/>
-        </p:spPr>
-        <p:txBody>
-          <a:bodyPr wrap="square" lIns="45720" rIns="45720" tIns="18288" bIns="18288" anchor="t">
-            <a:spAutoFit/>
-          </a:bodyPr>
-          <a:lstStyle/>
-          <a:p>
-            <a:pPr algn="l">
-              <a:lnSpc>
-                <a:spcPct val="135000"/>
-              </a:lnSpc>
-            </a:pPr>
-            <a:r>
-              <a:rPr sz="1800" b="1" spc="-20">
+              <a:t>即時上網查</a:t>
+            </a:r>
+          </a:p>
+        </p:txBody>
+      </p:sp>
+      <p:sp>
+        <p:nvSpPr>
+          <p:cNvPr id="12" name="TextBox 11"/>
+          <p:cNvSpPr txBox="1"/>
+          <p:nvPr/>
+        </p:nvSpPr>
+        <p:spPr>
+          <a:xfrm>
+            <a:off x="914400" y="3575304"/>
+            <a:ext cx="5029200" cy="320040"/>
+          </a:xfrm>
+          <a:prstGeom prst="rect">
+            <a:avLst/>
+          </a:prstGeom>
+          <a:noFill/>
+        </p:spPr>
+        <p:txBody>
+          <a:bodyPr wrap="square" lIns="45720" rIns="45720" tIns="18288" bIns="18288" anchor="t">
+            <a:spAutoFit/>
+          </a:bodyPr>
+          <a:lstStyle/>
+          <a:p>
+            <a:pPr algn="l">
+              <a:lnSpc>
+                <a:spcPct val="135000"/>
+              </a:lnSpc>
+            </a:pPr>
+            <a:r>
+              <a:rPr sz="1600" b="1" spc="-20">
                 <a:solidFill>
                   <a:srgbClr val="111111"/>
                 </a:solidFill>
                 <a:latin typeface="Consolas"/>
               </a:rPr>
-              <a:t>🔍  GoogleSearch</a:t>
-            </a:r>
-          </a:p>
-        </p:txBody>
-      </p:sp>
-      <p:sp>
-        <p:nvSpPr>
-          <p:cNvPr id="11" name="TextBox 10"/>
-          <p:cNvSpPr txBox="1"/>
-          <p:nvPr/>
-        </p:nvSpPr>
-        <p:spPr>
-          <a:xfrm>
-            <a:off x="6217920" y="3566160"/>
-            <a:ext cx="5212080" cy="365760"/>
-          </a:xfrm>
-          <a:prstGeom prst="rect">
-            <a:avLst/>
-          </a:prstGeom>
-          <a:noFill/>
-        </p:spPr>
-        <p:txBody>
-          <a:bodyPr wrap="square" lIns="45720" rIns="45720" tIns="18288" bIns="18288" anchor="t">
-            <a:spAutoFit/>
-          </a:bodyPr>
-          <a:lstStyle/>
-          <a:p>
-            <a:pPr algn="l">
-              <a:lnSpc>
-                <a:spcPct val="135000"/>
-              </a:lnSpc>
-            </a:pPr>
-            <a:r>
-              <a:rPr sz="1800" b="0" spc="-20">
-                <a:solidFill>
-                  <a:srgbClr val="3A3A3A"/>
-                </a:solidFill>
-                <a:latin typeface="Microsoft JhengHei"/>
-              </a:rPr>
-              <a:t>即時上網查</a:t>
-            </a:r>
-          </a:p>
-        </p:txBody>
-      </p:sp>
-      <p:sp>
-        <p:nvSpPr>
-          <p:cNvPr id="12" name="TextBox 11"/>
-          <p:cNvSpPr txBox="1"/>
-          <p:nvPr/>
-        </p:nvSpPr>
-        <p:spPr>
-          <a:xfrm>
-            <a:off x="914400" y="4023360"/>
-            <a:ext cx="5029200" cy="365760"/>
-          </a:xfrm>
-          <a:prstGeom prst="rect">
-            <a:avLst/>
-          </a:prstGeom>
-          <a:noFill/>
-        </p:spPr>
-        <p:txBody>
-          <a:bodyPr wrap="square" lIns="45720" rIns="45720" tIns="18288" bIns="18288" anchor="t">
-            <a:spAutoFit/>
-          </a:bodyPr>
-          <a:lstStyle/>
-          <a:p>
-            <a:pPr algn="l">
-              <a:lnSpc>
-                <a:spcPct val="135000"/>
-              </a:lnSpc>
-            </a:pPr>
-            <a:r>
-              <a:rPr sz="1800" b="1" spc="-20">
-                <a:solidFill>
-                  <a:srgbClr val="111111"/>
-                </a:solidFill>
-                <a:latin typeface="Consolas"/>
-              </a:rPr>
               <a:t>🌐  WebFetch</a:t>
             </a:r>
           </a:p>
@@ -32127,27 +32201,27 @@
         </p:nvSpPr>
         <p:spPr>
           <a:xfrm>
-            <a:off x="6217920" y="4023360"/>
-            <a:ext cx="5212080" cy="365760"/>
-          </a:xfrm>
-          <a:prstGeom prst="rect">
-            <a:avLst/>
-          </a:prstGeom>
-          <a:noFill/>
-        </p:spPr>
-        <p:txBody>
-          <a:bodyPr wrap="square" lIns="45720" rIns="45720" tIns="18288" bIns="18288" anchor="t">
-            <a:spAutoFit/>
-          </a:bodyPr>
-          <a:lstStyle/>
-          <a:p>
-            <a:pPr algn="l">
-              <a:lnSpc>
-                <a:spcPct val="135000"/>
-              </a:lnSpc>
-            </a:pPr>
-            <a:r>
-              <a:rPr sz="1800" b="0" spc="-20">
+            <a:off x="6217920" y="3575304"/>
+            <a:ext cx="5212080" cy="320040"/>
+          </a:xfrm>
+          <a:prstGeom prst="rect">
+            <a:avLst/>
+          </a:prstGeom>
+          <a:noFill/>
+        </p:spPr>
+        <p:txBody>
+          <a:bodyPr wrap="square" lIns="45720" rIns="45720" tIns="18288" bIns="18288" anchor="t">
+            <a:spAutoFit/>
+          </a:bodyPr>
+          <a:lstStyle/>
+          <a:p>
+            <a:pPr algn="l">
+              <a:lnSpc>
+                <a:spcPct val="135000"/>
+              </a:lnSpc>
+            </a:pPr>
+            <a:r>
+              <a:rPr sz="1600" b="0" spc="-20">
                 <a:solidFill>
                   <a:srgbClr val="3A3A3A"/>
                 </a:solidFill>
@@ -32166,7 +32240,7 @@
         </p:nvCxnSpPr>
         <p:spPr>
           <a:xfrm>
-            <a:off x="731520" y="4617720"/>
+            <a:off x="731520" y="4114800"/>
             <a:ext cx="10698480" cy="0"/>
           </a:xfrm>
           <a:prstGeom prst="line">
@@ -32201,33 +32275,33 @@
         </p:nvSpPr>
         <p:spPr>
           <a:xfrm>
-            <a:off x="731520" y="4754880"/>
-            <a:ext cx="10698480" cy="457200"/>
-          </a:xfrm>
-          <a:prstGeom prst="rect">
-            <a:avLst/>
-          </a:prstGeom>
-          <a:noFill/>
-        </p:spPr>
-        <p:txBody>
-          <a:bodyPr wrap="square" lIns="45720" rIns="45720" tIns="18288" bIns="18288" anchor="t">
-            <a:spAutoFit/>
-          </a:bodyPr>
-          <a:lstStyle/>
-          <a:p>
-            <a:pPr algn="l">
-              <a:lnSpc>
-                <a:spcPct val="135000"/>
-              </a:lnSpc>
-            </a:pPr>
-            <a:r>
-              <a:rPr sz="1800" b="1" spc="-30">
+            <a:off x="731520" y="4251960"/>
+            <a:ext cx="10698480" cy="411480"/>
+          </a:xfrm>
+          <a:prstGeom prst="rect">
+            <a:avLst/>
+          </a:prstGeom>
+          <a:noFill/>
+        </p:spPr>
+        <p:txBody>
+          <a:bodyPr wrap="square" lIns="45720" rIns="45720" tIns="18288" bIns="18288" anchor="t">
+            <a:spAutoFit/>
+          </a:bodyPr>
+          <a:lstStyle/>
+          <a:p>
+            <a:pPr algn="l">
+              <a:lnSpc>
+                <a:spcPct val="135000"/>
+              </a:lnSpc>
+            </a:pPr>
+            <a:r>
+              <a:rPr sz="1700" b="1" spc="-30">
                 <a:solidFill>
                   <a:srgbClr val="111111"/>
                 </a:solidFill>
                 <a:latin typeface="Microsoft JhengHei"/>
               </a:rPr>
-              <a:t>每次它要動手，會先問你「可以嗎？」</a:t>
+              <a:t>三層保險（事前 → 事中 → 事後）：</a:t>
             </a:r>
           </a:p>
         </p:txBody>
@@ -32240,79 +32314,352 @@
         </p:nvSpPr>
         <p:spPr>
           <a:xfrm>
-            <a:off x="914400" y="5349240"/>
-            <a:ext cx="10698480" cy="365760"/>
-          </a:xfrm>
-          <a:prstGeom prst="rect">
-            <a:avLst/>
-          </a:prstGeom>
-          <a:noFill/>
-        </p:spPr>
-        <p:txBody>
-          <a:bodyPr wrap="square" lIns="45720" rIns="45720" tIns="18288" bIns="18288" anchor="t">
-            <a:spAutoFit/>
-          </a:bodyPr>
-          <a:lstStyle/>
-          <a:p>
-            <a:pPr algn="l">
-              <a:lnSpc>
-                <a:spcPct val="135000"/>
-              </a:lnSpc>
-            </a:pPr>
-            <a:r>
-              <a:rPr sz="1500" b="0" spc="-20">
+            <a:off x="914400" y="4800600"/>
+            <a:ext cx="914400" cy="365760"/>
+          </a:xfrm>
+          <a:prstGeom prst="rect">
+            <a:avLst/>
+          </a:prstGeom>
+          <a:noFill/>
+        </p:spPr>
+        <p:txBody>
+          <a:bodyPr wrap="square" lIns="45720" rIns="45720" tIns="18288" bIns="18288" anchor="t">
+            <a:spAutoFit/>
+          </a:bodyPr>
+          <a:lstStyle/>
+          <a:p>
+            <a:pPr algn="l">
+              <a:lnSpc>
+                <a:spcPct val="135000"/>
+              </a:lnSpc>
+            </a:pPr>
+            <a:r>
+              <a:rPr sz="1400" b="1" spc="100">
                 <a:solidFill>
                   <a:srgbClr val="156B4A"/>
                 </a:solidFill>
+                <a:latin typeface="Consolas"/>
+              </a:rPr>
+              <a:t>事前</a:t>
+            </a:r>
+          </a:p>
+        </p:txBody>
+      </p:sp>
+      <p:sp>
+        <p:nvSpPr>
+          <p:cNvPr id="17" name="TextBox 16"/>
+          <p:cNvSpPr txBox="1"/>
+          <p:nvPr/>
+        </p:nvSpPr>
+        <p:spPr>
+          <a:xfrm>
+            <a:off x="1920240" y="4800600"/>
+            <a:ext cx="5029200" cy="365760"/>
+          </a:xfrm>
+          <a:prstGeom prst="rect">
+            <a:avLst/>
+          </a:prstGeom>
+          <a:noFill/>
+        </p:spPr>
+        <p:txBody>
+          <a:bodyPr wrap="square" lIns="45720" rIns="45720" tIns="18288" bIns="18288" anchor="t">
+            <a:spAutoFit/>
+          </a:bodyPr>
+          <a:lstStyle/>
+          <a:p>
+            <a:pPr algn="l">
+              <a:lnSpc>
+                <a:spcPct val="135000"/>
+              </a:lnSpc>
+            </a:pPr>
+            <a:r>
+              <a:rPr sz="1400" b="1" spc="-20">
+                <a:solidFill>
+                  <a:srgbClr val="111111"/>
+                </a:solidFill>
                 <a:latin typeface="Microsoft JhengHei"/>
               </a:rPr>
-              <a:t>首次啟動：逐資料夾信任授權  ← 只信你自己的工作區</a:t>
-            </a:r>
-          </a:p>
-        </p:txBody>
-      </p:sp>
-      <p:sp>
-        <p:nvSpPr>
-          <p:cNvPr id="17" name="TextBox 16"/>
-          <p:cNvSpPr txBox="1"/>
-          <p:nvPr/>
-        </p:nvSpPr>
-        <p:spPr>
-          <a:xfrm>
-            <a:off x="914400" y="5760720"/>
-            <a:ext cx="10698480" cy="365760"/>
-          </a:xfrm>
-          <a:prstGeom prst="rect">
-            <a:avLst/>
-          </a:prstGeom>
-          <a:noFill/>
-        </p:spPr>
-        <p:txBody>
-          <a:bodyPr wrap="square" lIns="45720" rIns="45720" tIns="18288" bIns="18288" anchor="t">
-            <a:spAutoFit/>
-          </a:bodyPr>
-          <a:lstStyle/>
-          <a:p>
-            <a:pPr algn="l">
-              <a:lnSpc>
-                <a:spcPct val="135000"/>
-              </a:lnSpc>
-            </a:pPr>
-            <a:r>
-              <a:rPr sz="1500" b="0" spc="-20">
+              <a:t>首次啟動：逐資料夾信任授權</a:t>
+            </a:r>
+          </a:p>
+        </p:txBody>
+      </p:sp>
+      <p:sp>
+        <p:nvSpPr>
+          <p:cNvPr id="18" name="TextBox 17"/>
+          <p:cNvSpPr txBox="1"/>
+          <p:nvPr/>
+        </p:nvSpPr>
+        <p:spPr>
+          <a:xfrm>
+            <a:off x="7040880" y="4800600"/>
+            <a:ext cx="4389120" cy="365760"/>
+          </a:xfrm>
+          <a:prstGeom prst="rect">
+            <a:avLst/>
+          </a:prstGeom>
+          <a:noFill/>
+        </p:spPr>
+        <p:txBody>
+          <a:bodyPr wrap="square" lIns="45720" rIns="45720" tIns="18288" bIns="18288" anchor="t">
+            <a:spAutoFit/>
+          </a:bodyPr>
+          <a:lstStyle/>
+          <a:p>
+            <a:pPr algn="l">
+              <a:lnSpc>
+                <a:spcPct val="135000"/>
+              </a:lnSpc>
+            </a:pPr>
+            <a:r>
+              <a:rPr sz="1300" b="0" spc="-10">
+                <a:solidFill>
+                  <a:srgbClr val="8A8A8A"/>
+                </a:solidFill>
+                <a:latin typeface="Microsoft JhengHei"/>
+              </a:rPr>
+              <a:t>只信你自己的工作區</a:t>
+            </a:r>
+          </a:p>
+        </p:txBody>
+      </p:sp>
+      <p:sp>
+        <p:nvSpPr>
+          <p:cNvPr id="19" name="TextBox 18"/>
+          <p:cNvSpPr txBox="1"/>
+          <p:nvPr/>
+        </p:nvSpPr>
+        <p:spPr>
+          <a:xfrm>
+            <a:off x="914400" y="5303520"/>
+            <a:ext cx="914400" cy="365760"/>
+          </a:xfrm>
+          <a:prstGeom prst="rect">
+            <a:avLst/>
+          </a:prstGeom>
+          <a:noFill/>
+        </p:spPr>
+        <p:txBody>
+          <a:bodyPr wrap="square" lIns="45720" rIns="45720" tIns="18288" bIns="18288" anchor="t">
+            <a:spAutoFit/>
+          </a:bodyPr>
+          <a:lstStyle/>
+          <a:p>
+            <a:pPr algn="l">
+              <a:lnSpc>
+                <a:spcPct val="135000"/>
+              </a:lnSpc>
+            </a:pPr>
+            <a:r>
+              <a:rPr sz="1400" b="1" spc="100">
                 <a:solidFill>
                   <a:srgbClr val="156B4A"/>
                 </a:solidFill>
+                <a:latin typeface="Consolas"/>
+              </a:rPr>
+              <a:t>事中</a:t>
+            </a:r>
+          </a:p>
+        </p:txBody>
+      </p:sp>
+      <p:sp>
+        <p:nvSpPr>
+          <p:cNvPr id="20" name="TextBox 19"/>
+          <p:cNvSpPr txBox="1"/>
+          <p:nvPr/>
+        </p:nvSpPr>
+        <p:spPr>
+          <a:xfrm>
+            <a:off x="1920240" y="5303520"/>
+            <a:ext cx="5029200" cy="365760"/>
+          </a:xfrm>
+          <a:prstGeom prst="rect">
+            <a:avLst/>
+          </a:prstGeom>
+          <a:noFill/>
+        </p:spPr>
+        <p:txBody>
+          <a:bodyPr wrap="square" lIns="45720" rIns="45720" tIns="18288" bIns="18288" anchor="t">
+            <a:spAutoFit/>
+          </a:bodyPr>
+          <a:lstStyle/>
+          <a:p>
+            <a:pPr algn="l">
+              <a:lnSpc>
+                <a:spcPct val="135000"/>
+              </a:lnSpc>
+            </a:pPr>
+            <a:r>
+              <a:rPr sz="1400" b="1" spc="-20">
+                <a:solidFill>
+                  <a:srgbClr val="111111"/>
+                </a:solidFill>
                 <a:latin typeface="Microsoft JhengHei"/>
               </a:rPr>
-              <a:t>每次動手：先問你「可以嗎？」  ← 確認模式 = 你的保護傘</a:t>
+              <a:t>每次動手：先問你「可以嗎？」</a:t>
+            </a:r>
+          </a:p>
+        </p:txBody>
+      </p:sp>
+      <p:sp>
+        <p:nvSpPr>
+          <p:cNvPr id="21" name="TextBox 20"/>
+          <p:cNvSpPr txBox="1"/>
+          <p:nvPr/>
+        </p:nvSpPr>
+        <p:spPr>
+          <a:xfrm>
+            <a:off x="7040880" y="5303520"/>
+            <a:ext cx="4389120" cy="365760"/>
+          </a:xfrm>
+          <a:prstGeom prst="rect">
+            <a:avLst/>
+          </a:prstGeom>
+          <a:noFill/>
+        </p:spPr>
+        <p:txBody>
+          <a:bodyPr wrap="square" lIns="45720" rIns="45720" tIns="18288" bIns="18288" anchor="t">
+            <a:spAutoFit/>
+          </a:bodyPr>
+          <a:lstStyle/>
+          <a:p>
+            <a:pPr algn="l">
+              <a:lnSpc>
+                <a:spcPct val="135000"/>
+              </a:lnSpc>
+            </a:pPr>
+            <a:r>
+              <a:rPr sz="1300" b="0" spc="-10">
+                <a:solidFill>
+                  <a:srgbClr val="8A8A8A"/>
+                </a:solidFill>
+                <a:latin typeface="Microsoft JhengHei"/>
+              </a:rPr>
+              <a:t>確認模式 = 動檔/跑指令前停下</a:t>
+            </a:r>
+          </a:p>
+        </p:txBody>
+      </p:sp>
+      <p:sp>
+        <p:nvSpPr>
+          <p:cNvPr id="22" name="TextBox 21"/>
+          <p:cNvSpPr txBox="1"/>
+          <p:nvPr/>
+        </p:nvSpPr>
+        <p:spPr>
+          <a:xfrm>
+            <a:off x="914400" y="5806440"/>
+            <a:ext cx="914400" cy="365760"/>
+          </a:xfrm>
+          <a:prstGeom prst="rect">
+            <a:avLst/>
+          </a:prstGeom>
+          <a:noFill/>
+        </p:spPr>
+        <p:txBody>
+          <a:bodyPr wrap="square" lIns="45720" rIns="45720" tIns="18288" bIns="18288" anchor="t">
+            <a:spAutoFit/>
+          </a:bodyPr>
+          <a:lstStyle/>
+          <a:p>
+            <a:pPr algn="l">
+              <a:lnSpc>
+                <a:spcPct val="135000"/>
+              </a:lnSpc>
+            </a:pPr>
+            <a:r>
+              <a:rPr sz="1400" b="1" spc="100">
+                <a:solidFill>
+                  <a:srgbClr val="156B4A"/>
+                </a:solidFill>
+                <a:latin typeface="Consolas"/>
+              </a:rPr>
+              <a:t>事後</a:t>
+            </a:r>
+          </a:p>
+        </p:txBody>
+      </p:sp>
+      <p:sp>
+        <p:nvSpPr>
+          <p:cNvPr id="23" name="TextBox 22"/>
+          <p:cNvSpPr txBox="1"/>
+          <p:nvPr/>
+        </p:nvSpPr>
+        <p:spPr>
+          <a:xfrm>
+            <a:off x="1920240" y="5806440"/>
+            <a:ext cx="5029200" cy="365760"/>
+          </a:xfrm>
+          <a:prstGeom prst="rect">
+            <a:avLst/>
+          </a:prstGeom>
+          <a:noFill/>
+        </p:spPr>
+        <p:txBody>
+          <a:bodyPr wrap="square" lIns="45720" rIns="45720" tIns="18288" bIns="18288" anchor="t">
+            <a:spAutoFit/>
+          </a:bodyPr>
+          <a:lstStyle/>
+          <a:p>
+            <a:pPr algn="l">
+              <a:lnSpc>
+                <a:spcPct val="135000"/>
+              </a:lnSpc>
+            </a:pPr>
+            <a:r>
+              <a:rPr sz="1400" b="1" spc="-20">
+                <a:solidFill>
+                  <a:srgbClr val="111111"/>
+                </a:solidFill>
+                <a:latin typeface="Microsoft JhengHei"/>
+              </a:rPr>
+              <a:t>改錯了：打 /restore 選快照回滾</a:t>
+            </a:r>
+          </a:p>
+        </p:txBody>
+      </p:sp>
+      <p:sp>
+        <p:nvSpPr>
+          <p:cNvPr id="24" name="TextBox 23"/>
+          <p:cNvSpPr txBox="1"/>
+          <p:nvPr/>
+        </p:nvSpPr>
+        <p:spPr>
+          <a:xfrm>
+            <a:off x="7040880" y="5806440"/>
+            <a:ext cx="4389120" cy="365760"/>
+          </a:xfrm>
+          <a:prstGeom prst="rect">
+            <a:avLst/>
+          </a:prstGeom>
+          <a:noFill/>
+        </p:spPr>
+        <p:txBody>
+          <a:bodyPr wrap="square" lIns="45720" rIns="45720" tIns="18288" bIns="18288" anchor="t">
+            <a:spAutoFit/>
+          </a:bodyPr>
+          <a:lstStyle/>
+          <a:p>
+            <a:pPr algn="l">
+              <a:lnSpc>
+                <a:spcPct val="135000"/>
+              </a:lnSpc>
+            </a:pPr>
+            <a:r>
+              <a:rPr sz="1300" b="0" spc="-10">
+                <a:solidFill>
+                  <a:srgbClr val="8A8A8A"/>
+                </a:solidFill>
+                <a:latin typeface="Microsoft JhengHei"/>
+              </a:rPr>
+              <a:t>比 git reset 安全（不動 git 歷史）</a:t>
             </a:r>
           </a:p>
         </p:txBody>
       </p:sp>
       <p:cxnSp>
         <p:nvCxnSpPr>
-          <p:cNvPr id="18" name="Connector 17"/>
+          <p:cNvPr id="25" name="Connector 24"/>
           <p:cNvCxnSpPr/>
           <p:nvPr/>
         </p:nvCxnSpPr>
@@ -32347,7 +32694,7 @@
       </p:cxnSp>
       <p:sp>
         <p:nvSpPr>
-          <p:cNvPr id="19" name="TextBox 18"/>
+          <p:cNvPr id="26" name="TextBox 25"/>
           <p:cNvSpPr txBox="1"/>
           <p:nvPr/>
         </p:nvSpPr>
@@ -32386,7 +32733,7 @@
       </p:sp>
       <p:sp>
         <p:nvSpPr>
-          <p:cNvPr id="20" name="TextBox 19"/>
+          <p:cNvPr id="27" name="TextBox 26"/>
           <p:cNvSpPr txBox="1"/>
           <p:nvPr/>
         </p:nvSpPr>

</xml_diff>